<commit_message>
feat: message frame with the team's anchor words
Decisions, Optimized, Clinician-Centered, Growth: the four-corner frame,
a four-column version, and an example story slide, built on the deck's
Compassus light master.

Co-Authored-By: Claude Opus 5.5 <noreply@anthropic.com>
Claude-Session: https://claude.ai/code/session_018jUds38b5frrRM32hHSBXH
</commit_message>
<xml_diff>
--- a/agents/compassus-capacity-pm/artifacts/sme-introduction-deck/Compassus-Message-Frame.pptx
+++ b/agents/compassus-capacity-pm/artifacts/sme-introduction-deck/Compassus-Message-Frame.pptx
@@ -6,9 +6,11 @@
   </p:sldMasterIdLst>
   <p:sldIdLst>
     <p:sldId id="256" r:id="rId2"/>
+    <p:sldId id="257" r:id="rId3"/>
+    <p:sldId id="258" r:id="rId4"/>
   </p:sldIdLst>
   <p:notesMasterIdLst>
-    <p:notesMasterId r:id="rId3"/>
+    <p:notesMasterId r:id="rId5"/>
   </p:notesMasterIdLst>
   <p:sldSz cx="12192000" cy="6858000"/>
   <p:notesSz cx="6858000" cy="12192000"/>
@@ -502,7 +504,7 @@
           <a:p>
             <a:r>
               <a:rPr lang="en-US" dirty="0"/>
-              <a:t>Read the frame in order: 1 Problem, 2 Solution, 3 Approach, 4 Result. Problem: capacity information is fragmented across spreadsheets, systems and individual memory, and PCCs and clinicians absorb the cost. Solution: one clear view of capacity, with automation and recommendations that explain themselves. Approach: field-led, with our SMEs testing vendors on real scenarios, capacity first, then a measured pilot. Result: growth, as branches accept referrals with confidence and people get time back for the work that matters.</a:t>
+              <a:t>The four anchor words stay the same, always: Decisions, Optimized, Clinician-Centered, Growth. What changes is how you illustrate them for the listener. Problem: decisions are hard, disjointed and complex. Solution: optimized. Approach: clinician-centered. Result: growth, in the business, in employee retention, and in patients served.</a:t>
             </a:r>
             <a:endParaRPr lang="en-US" dirty="0"/>
           </a:p>
@@ -526,6 +528,182 @@
             <a:fld id="{F7021451-1387-4CA6-816F-3879F97B5CBC}" type="slidenum">
               <a:rPr lang="en-US"/>
               <a:t>1</a:t>
+            </a:fld>
+            <a:endParaRPr lang="en-US"/>
+          </a:p>
+        </p:txBody>
+      </p:sp>
+    </p:spTree>
+    <p:extLst>
+      <p:ext uri="{BB962C8B-B14F-4D97-AF65-F5344CB8AC3E}">
+        <p14:creationId xmlns:p14="http://schemas.microsoft.com/office/powerpoint/2010/main" val="1024086991"/>
+      </p:ext>
+    </p:extLst>
+  </p:cSld>
+  <p:clrMapOvr>
+    <a:masterClrMapping/>
+  </p:clrMapOvr>
+</p:notes>
+</file>
+
+<file path=ppt/notesSlides/notesSlide2.xml><?xml version="1.0" encoding="utf-8"?>
+<p:notes xmlns:a="http://schemas.openxmlformats.org/drawingml/2006/main" xmlns:r="http://schemas.openxmlformats.org/officeDocument/2006/relationships" xmlns:p="http://schemas.openxmlformats.org/presentationml/2006/main">
+  <p:cSld>
+    <p:spTree>
+      <p:nvGrpSpPr>
+        <p:cNvPr id="1" name=""/>
+        <p:cNvGrpSpPr/>
+        <p:nvPr/>
+      </p:nvGrpSpPr>
+      <p:grpSpPr>
+        <a:xfrm>
+          <a:off x="0" y="0"/>
+          <a:ext cx="0" cy="0"/>
+          <a:chOff x="0" y="0"/>
+          <a:chExt cx="0" cy="0"/>
+        </a:xfrm>
+      </p:grpSpPr>
+      <p:sp>
+        <p:nvSpPr>
+          <p:cNvPr id="2" name="Slide Image Placeholder 1"/>
+          <p:cNvSpPr>
+            <a:spLocks noGrp="1" noRot="1" noChangeAspect="1"/>
+          </p:cNvSpPr>
+          <p:nvPr>
+            <p:ph type="sldImg"/>
+          </p:nvPr>
+        </p:nvSpPr>
+        <p:spPr/>
+      </p:sp>
+      <p:sp>
+        <p:nvSpPr>
+          <p:cNvPr id="3" name="Notes Placeholder 2"/>
+          <p:cNvSpPr>
+            <a:spLocks noGrp="1"/>
+          </p:cNvSpPr>
+          <p:nvPr>
+            <p:ph type="body" idx="1"/>
+          </p:nvPr>
+        </p:nvSpPr>
+        <p:spPr/>
+        <p:txBody>
+          <a:bodyPr/>
+          <a:lstStyle/>
+          <a:p>
+            <a:r>
+              <a:rPr lang="en-US" dirty="0"/>
+              <a:t>The same four anchor words, read left to right as one sentence: today every branch runs on decisions that are hard, disjointed and complex; our solution must be optimized; our approach is clinician-centered; the result is growth.</a:t>
+            </a:r>
+            <a:endParaRPr lang="en-US" dirty="0"/>
+          </a:p>
+        </p:txBody>
+      </p:sp>
+      <p:sp>
+        <p:nvSpPr>
+          <p:cNvPr id="4" name="Slide Number Placeholder 3"/>
+          <p:cNvSpPr>
+            <a:spLocks noGrp="1"/>
+          </p:cNvSpPr>
+          <p:nvPr>
+            <p:ph type="sldNum" sz="quarter" idx="10"/>
+          </p:nvPr>
+        </p:nvSpPr>
+        <p:spPr/>
+        <p:txBody>
+          <a:bodyPr/>
+          <a:lstStyle/>
+          <a:p>
+            <a:fld id="{F7021451-1387-4CA6-816F-3879F97B5CBC}" type="slidenum">
+              <a:rPr lang="en-US"/>
+              <a:t>2</a:t>
+            </a:fld>
+            <a:endParaRPr lang="en-US"/>
+          </a:p>
+        </p:txBody>
+      </p:sp>
+    </p:spTree>
+    <p:extLst>
+      <p:ext uri="{BB962C8B-B14F-4D97-AF65-F5344CB8AC3E}">
+        <p14:creationId xmlns:p14="http://schemas.microsoft.com/office/powerpoint/2010/main" val="1024086991"/>
+      </p:ext>
+    </p:extLst>
+  </p:cSld>
+  <p:clrMapOvr>
+    <a:masterClrMapping/>
+  </p:clrMapOvr>
+</p:notes>
+</file>
+
+<file path=ppt/notesSlides/notesSlide3.xml><?xml version="1.0" encoding="utf-8"?>
+<p:notes xmlns:a="http://schemas.openxmlformats.org/drawingml/2006/main" xmlns:r="http://schemas.openxmlformats.org/officeDocument/2006/relationships" xmlns:p="http://schemas.openxmlformats.org/presentationml/2006/main">
+  <p:cSld>
+    <p:spTree>
+      <p:nvGrpSpPr>
+        <p:cNvPr id="1" name=""/>
+        <p:cNvGrpSpPr/>
+        <p:nvPr/>
+      </p:nvGrpSpPr>
+      <p:grpSpPr>
+        <a:xfrm>
+          <a:off x="0" y="0"/>
+          <a:ext cx="0" cy="0"/>
+          <a:chOff x="0" y="0"/>
+          <a:chExt cx="0" cy="0"/>
+        </a:xfrm>
+      </p:grpSpPr>
+      <p:sp>
+        <p:nvSpPr>
+          <p:cNvPr id="2" name="Slide Image Placeholder 1"/>
+          <p:cNvSpPr>
+            <a:spLocks noGrp="1" noRot="1" noChangeAspect="1"/>
+          </p:cNvSpPr>
+          <p:nvPr>
+            <p:ph type="sldImg"/>
+          </p:nvPr>
+        </p:nvSpPr>
+        <p:spPr/>
+      </p:sp>
+      <p:sp>
+        <p:nvSpPr>
+          <p:cNvPr id="3" name="Notes Placeholder 2"/>
+          <p:cNvSpPr>
+            <a:spLocks noGrp="1"/>
+          </p:cNvSpPr>
+          <p:nvPr>
+            <p:ph type="body" idx="1"/>
+          </p:nvPr>
+        </p:nvSpPr>
+        <p:spPr/>
+        <p:txBody>
+          <a:bodyPr/>
+          <a:lstStyle/>
+          <a:p>
+            <a:r>
+              <a:rPr lang="en-US" dirty="0"/>
+              <a:t>Use this as a model, not a script. Keep the four anchor words exactly as they are, and swap in facts and examples from your own branch: a decision that went wrong last week, the spreadsheet you maintain, the clinician who stayed because the schedule worked for them.</a:t>
+            </a:r>
+            <a:endParaRPr lang="en-US" dirty="0"/>
+          </a:p>
+        </p:txBody>
+      </p:sp>
+      <p:sp>
+        <p:nvSpPr>
+          <p:cNvPr id="4" name="Slide Number Placeholder 3"/>
+          <p:cNvSpPr>
+            <a:spLocks noGrp="1"/>
+          </p:cNvSpPr>
+          <p:nvPr>
+            <p:ph type="sldNum" sz="quarter" idx="10"/>
+          </p:nvPr>
+        </p:nvSpPr>
+        <p:spPr/>
+        <p:txBody>
+          <a:bodyPr/>
+          <a:lstStyle/>
+          <a:p>
+            <a:fld id="{F7021451-1387-4CA6-816F-3879F97B5CBC}" type="slidenum">
+              <a:rPr lang="en-US"/>
+              <a:t>3</a:t>
             </a:fld>
             <a:endParaRPr lang="en-US"/>
           </a:p>
@@ -1201,7 +1379,7 @@
                 <a:ea typeface="Arial" pitchFamily="34" charset="-122"/>
                 <a:cs typeface="Arial" pitchFamily="34" charset="-120"/>
               </a:rPr>
-              <a:t>MESSAGE FRAME</a:t>
+              <a:t>MESSAGE FRAME · OUR ANCHOR WORDS</a:t>
             </a:r>
             <a:endParaRPr lang="en-US" sz="1200" dirty="0"/>
           </a:p>
@@ -1242,7 +1420,7 @@
                 <a:ea typeface="Maven Pro" pitchFamily="34" charset="-122"/>
                 <a:cs typeface="Maven Pro" pitchFamily="34" charset="-120"/>
               </a:rPr>
-              <a:t>Our key words</a:t>
+              <a:t>Four words every leader can repeat</a:t>
             </a:r>
             <a:endParaRPr lang="en-US" sz="4000" dirty="0"/>
           </a:p>
@@ -1256,7 +1434,7 @@
         </p:nvSpPr>
         <p:spPr>
           <a:xfrm>
-            <a:off x="3429000" y="4064000"/>
+            <a:off x="3302000" y="4127500"/>
             <a:ext cx="2413000" cy="1333500"/>
           </a:xfrm>
           <a:prstGeom prst="rect">
@@ -1276,8 +1454,8 @@
         </p:nvSpPr>
         <p:spPr>
           <a:xfrm>
-            <a:off x="3632200" y="4267200"/>
-            <a:ext cx="2006600" cy="215900"/>
+            <a:off x="3505200" y="4318000"/>
+            <a:ext cx="2006600" cy="190500"/>
           </a:xfrm>
           <a:prstGeom prst="rect">
             <a:avLst/>
@@ -1293,7 +1471,7 @@
               <a:buNone/>
             </a:pPr>
             <a:r>
-              <a:rPr lang="en-US" sz="1200" b="1" spc="150" kern="0" dirty="0">
+              <a:rPr lang="en-US" sz="1100" b="1" spc="150" kern="0" dirty="0">
                 <a:solidFill>
                   <a:srgbClr val="CE8E00"/>
                 </a:solidFill>
@@ -1301,9 +1479,9 @@
                 <a:ea typeface="Arial" pitchFamily="34" charset="-122"/>
                 <a:cs typeface="Arial" pitchFamily="34" charset="-120"/>
               </a:rPr>
-              <a:t>1  ·  PROBLEM</a:t>
-            </a:r>
-            <a:endParaRPr lang="en-US" sz="1200" dirty="0"/>
+              <a:t>PROBLEM</a:t>
+            </a:r>
+            <a:endParaRPr lang="en-US" sz="1100" dirty="0"/>
           </a:p>
         </p:txBody>
       </p:sp>
@@ -1315,8 +1493,8 @@
         </p:nvSpPr>
         <p:spPr>
           <a:xfrm>
-            <a:off x="3632200" y="4584700"/>
-            <a:ext cx="2006600" cy="609600"/>
+            <a:off x="3505200" y="4533900"/>
+            <a:ext cx="2006600" cy="762000"/>
           </a:xfrm>
           <a:prstGeom prst="rect">
             <a:avLst/>
@@ -1329,6 +1507,9 @@
           <a:lstStyle/>
           <a:p>
             <a:pPr algn="l" indent="0" marL="0">
+              <a:lnSpc>
+                <a:spcPct val="95000"/>
+              </a:lnSpc>
               <a:buNone/>
             </a:pPr>
             <a:r>
@@ -1340,7 +1521,7 @@
                 <a:ea typeface="Maven Pro" pitchFamily="34" charset="-122"/>
                 <a:cs typeface="Maven Pro" pitchFamily="34" charset="-120"/>
               </a:rPr>
-              <a:t>Fragmented</a:t>
+              <a:t>DECISIONS</a:t>
             </a:r>
             <a:endParaRPr lang="en-US" sz="2600" dirty="0"/>
           </a:p>
@@ -1354,7 +1535,7 @@
         </p:nvSpPr>
         <p:spPr>
           <a:xfrm>
-            <a:off x="3429000" y="2095500"/>
+            <a:off x="3302000" y="2095500"/>
             <a:ext cx="2413000" cy="1333500"/>
           </a:xfrm>
           <a:prstGeom prst="rect">
@@ -1374,8 +1555,8 @@
         </p:nvSpPr>
         <p:spPr>
           <a:xfrm>
-            <a:off x="3632200" y="2298700"/>
-            <a:ext cx="2006600" cy="215900"/>
+            <a:off x="3505200" y="2286000"/>
+            <a:ext cx="2006600" cy="190500"/>
           </a:xfrm>
           <a:prstGeom prst="rect">
             <a:avLst/>
@@ -1391,7 +1572,7 @@
               <a:buNone/>
             </a:pPr>
             <a:r>
-              <a:rPr lang="en-US" sz="1200" b="1" spc="150" kern="0" dirty="0">
+              <a:rPr lang="en-US" sz="1100" b="1" spc="150" kern="0" dirty="0">
                 <a:solidFill>
                   <a:srgbClr val="CE8E00"/>
                 </a:solidFill>
@@ -1399,9 +1580,9 @@
                 <a:ea typeface="Arial" pitchFamily="34" charset="-122"/>
                 <a:cs typeface="Arial" pitchFamily="34" charset="-120"/>
               </a:rPr>
-              <a:t>2  ·  SOLUTION</a:t>
-            </a:r>
-            <a:endParaRPr lang="en-US" sz="1200" dirty="0"/>
+              <a:t>SOLUTION</a:t>
+            </a:r>
+            <a:endParaRPr lang="en-US" sz="1100" dirty="0"/>
           </a:p>
         </p:txBody>
       </p:sp>
@@ -1413,8 +1594,8 @@
         </p:nvSpPr>
         <p:spPr>
           <a:xfrm>
-            <a:off x="3632200" y="2616200"/>
-            <a:ext cx="2006600" cy="609600"/>
+            <a:off x="3505200" y="2501900"/>
+            <a:ext cx="2006600" cy="762000"/>
           </a:xfrm>
           <a:prstGeom prst="rect">
             <a:avLst/>
@@ -1427,6 +1608,9 @@
           <a:lstStyle/>
           <a:p>
             <a:pPr algn="l" indent="0" marL="0">
+              <a:lnSpc>
+                <a:spcPct val="95000"/>
+              </a:lnSpc>
               <a:buNone/>
             </a:pPr>
             <a:r>
@@ -1438,7 +1622,7 @@
                 <a:ea typeface="Maven Pro" pitchFamily="34" charset="-122"/>
                 <a:cs typeface="Maven Pro" pitchFamily="34" charset="-120"/>
               </a:rPr>
-              <a:t>Visibility</a:t>
+              <a:t>OPTIMIZED</a:t>
             </a:r>
             <a:endParaRPr lang="en-US" sz="2600" dirty="0"/>
           </a:p>
@@ -1452,7 +1636,7 @@
         </p:nvSpPr>
         <p:spPr>
           <a:xfrm>
-            <a:off x="6350000" y="2095500"/>
+            <a:off x="6477000" y="2095500"/>
             <a:ext cx="2413000" cy="1333500"/>
           </a:xfrm>
           <a:prstGeom prst="rect">
@@ -1472,8 +1656,8 @@
         </p:nvSpPr>
         <p:spPr>
           <a:xfrm>
-            <a:off x="6553200" y="2298700"/>
-            <a:ext cx="2006600" cy="215900"/>
+            <a:off x="6680200" y="2286000"/>
+            <a:ext cx="2006600" cy="190500"/>
           </a:xfrm>
           <a:prstGeom prst="rect">
             <a:avLst/>
@@ -1489,7 +1673,7 @@
               <a:buNone/>
             </a:pPr>
             <a:r>
-              <a:rPr lang="en-US" sz="1200" b="1" spc="150" kern="0" dirty="0">
+              <a:rPr lang="en-US" sz="1100" b="1" spc="150" kern="0" dirty="0">
                 <a:solidFill>
                   <a:srgbClr val="CE8E00"/>
                 </a:solidFill>
@@ -1497,9 +1681,9 @@
                 <a:ea typeface="Arial" pitchFamily="34" charset="-122"/>
                 <a:cs typeface="Arial" pitchFamily="34" charset="-120"/>
               </a:rPr>
-              <a:t>3  ·  APPROACH</a:t>
-            </a:r>
-            <a:endParaRPr lang="en-US" sz="1200" dirty="0"/>
+              <a:t>APPROACH</a:t>
+            </a:r>
+            <a:endParaRPr lang="en-US" sz="1100" dirty="0"/>
           </a:p>
         </p:txBody>
       </p:sp>
@@ -1511,8 +1695,8 @@
         </p:nvSpPr>
         <p:spPr>
           <a:xfrm>
-            <a:off x="6553200" y="2616200"/>
-            <a:ext cx="2006600" cy="609600"/>
+            <a:off x="6680200" y="2501900"/>
+            <a:ext cx="2006600" cy="762000"/>
           </a:xfrm>
           <a:prstGeom prst="rect">
             <a:avLst/>
@@ -1525,10 +1709,13 @@
           <a:lstStyle/>
           <a:p>
             <a:pPr algn="l" indent="0" marL="0">
-              <a:buNone/>
-            </a:pPr>
-            <a:r>
-              <a:rPr lang="en-US" sz="2600" dirty="0">
+              <a:lnSpc>
+                <a:spcPct val="95000"/>
+              </a:lnSpc>
+              <a:buNone/>
+            </a:pPr>
+            <a:r>
+              <a:rPr lang="en-US" sz="2100" dirty="0">
                 <a:solidFill>
                   <a:srgbClr val="F8F6F1"/>
                 </a:solidFill>
@@ -1536,9 +1723,29 @@
                 <a:ea typeface="Maven Pro" pitchFamily="34" charset="-122"/>
                 <a:cs typeface="Maven Pro" pitchFamily="34" charset="-120"/>
               </a:rPr>
-              <a:t>Field-led</a:t>
-            </a:r>
-            <a:endParaRPr lang="en-US" sz="2600" dirty="0"/>
+              <a:t>CLINICIAN-</a:t>
+            </a:r>
+            <a:endParaRPr lang="en-US" sz="2100" dirty="0"/>
+          </a:p>
+          <a:p>
+            <a:pPr algn="l" indent="0" marL="0">
+              <a:lnSpc>
+                <a:spcPct val="95000"/>
+              </a:lnSpc>
+              <a:buNone/>
+            </a:pPr>
+            <a:r>
+              <a:rPr lang="en-US" sz="2100" dirty="0">
+                <a:solidFill>
+                  <a:srgbClr val="F8F6F1"/>
+                </a:solidFill>
+                <a:latin typeface="Maven Pro" pitchFamily="34" charset="0"/>
+                <a:ea typeface="Maven Pro" pitchFamily="34" charset="-122"/>
+                <a:cs typeface="Maven Pro" pitchFamily="34" charset="-120"/>
+              </a:rPr>
+              <a:t>CENTERED</a:t>
+            </a:r>
+            <a:endParaRPr lang="en-US" sz="2100" dirty="0"/>
           </a:p>
         </p:txBody>
       </p:sp>
@@ -1550,7 +1757,7 @@
         </p:nvSpPr>
         <p:spPr>
           <a:xfrm>
-            <a:off x="6350000" y="4064000"/>
+            <a:off x="6477000" y="4127500"/>
             <a:ext cx="2413000" cy="1333500"/>
           </a:xfrm>
           <a:prstGeom prst="rect">
@@ -1570,8 +1777,8 @@
         </p:nvSpPr>
         <p:spPr>
           <a:xfrm>
-            <a:off x="6553200" y="4267200"/>
-            <a:ext cx="2006600" cy="215900"/>
+            <a:off x="6680200" y="4318000"/>
+            <a:ext cx="2006600" cy="190500"/>
           </a:xfrm>
           <a:prstGeom prst="rect">
             <a:avLst/>
@@ -1587,7 +1794,7 @@
               <a:buNone/>
             </a:pPr>
             <a:r>
-              <a:rPr lang="en-US" sz="1200" b="1" spc="150" kern="0" dirty="0">
+              <a:rPr lang="en-US" sz="1100" b="1" spc="150" kern="0" dirty="0">
                 <a:solidFill>
                   <a:srgbClr val="CE8E00"/>
                 </a:solidFill>
@@ -1595,9 +1802,9 @@
                 <a:ea typeface="Arial" pitchFamily="34" charset="-122"/>
                 <a:cs typeface="Arial" pitchFamily="34" charset="-120"/>
               </a:rPr>
-              <a:t>4  ·  RESULT</a:t>
-            </a:r>
-            <a:endParaRPr lang="en-US" sz="1200" dirty="0"/>
+              <a:t>RESULT</a:t>
+            </a:r>
+            <a:endParaRPr lang="en-US" sz="1100" dirty="0"/>
           </a:p>
         </p:txBody>
       </p:sp>
@@ -1609,8 +1816,8 @@
         </p:nvSpPr>
         <p:spPr>
           <a:xfrm>
-            <a:off x="6553200" y="4584700"/>
-            <a:ext cx="2006600" cy="609600"/>
+            <a:off x="6680200" y="4533900"/>
+            <a:ext cx="2006600" cy="762000"/>
           </a:xfrm>
           <a:prstGeom prst="rect">
             <a:avLst/>
@@ -1623,6 +1830,9 @@
           <a:lstStyle/>
           <a:p>
             <a:pPr algn="l" indent="0" marL="0">
+              <a:lnSpc>
+                <a:spcPct val="95000"/>
+              </a:lnSpc>
               <a:buNone/>
             </a:pPr>
             <a:r>
@@ -1634,7 +1844,7 @@
                 <a:ea typeface="Maven Pro" pitchFamily="34" charset="-122"/>
                 <a:cs typeface="Maven Pro" pitchFamily="34" charset="-120"/>
               </a:rPr>
-              <a:t>Growth</a:t>
+              <a:t>GROWTH</a:t>
             </a:r>
             <a:endParaRPr lang="en-US" sz="2600" dirty="0"/>
           </a:p>
@@ -1648,8 +1858,8 @@
         </p:nvSpPr>
         <p:spPr>
           <a:xfrm>
-            <a:off x="4635500" y="3467100"/>
-            <a:ext cx="0" cy="558800"/>
+            <a:off x="4508500" y="3479800"/>
+            <a:ext cx="0" cy="596900"/>
           </a:xfrm>
           <a:prstGeom prst="line">
             <a:avLst/>
@@ -1672,8 +1882,8 @@
         </p:nvSpPr>
         <p:spPr>
           <a:xfrm>
-            <a:off x="5880100" y="2762250"/>
-            <a:ext cx="431800" cy="0"/>
+            <a:off x="5765800" y="2762250"/>
+            <a:ext cx="660400" cy="0"/>
           </a:xfrm>
           <a:prstGeom prst="line">
             <a:avLst/>
@@ -1696,8 +1906,8 @@
         </p:nvSpPr>
         <p:spPr>
           <a:xfrm>
-            <a:off x="7556500" y="3467100"/>
-            <a:ext cx="0" cy="558800"/>
+            <a:off x="7683500" y="3479800"/>
+            <a:ext cx="0" cy="596900"/>
           </a:xfrm>
           <a:prstGeom prst="line">
             <a:avLst/>
@@ -1720,8 +1930,8 @@
         </p:nvSpPr>
         <p:spPr>
           <a:xfrm>
-            <a:off x="812800" y="4064000"/>
-            <a:ext cx="2349500" cy="1333500"/>
+            <a:off x="812800" y="4127500"/>
+            <a:ext cx="2235200" cy="1333500"/>
           </a:xfrm>
           <a:prstGeom prst="rect">
             <a:avLst/>
@@ -1733,7 +1943,7 @@
           <a:bodyPr wrap="square" lIns="0" tIns="0" rIns="0" bIns="0" rtlCol="0" anchor="ctr"/>
           <a:lstStyle/>
           <a:p>
-            <a:pPr algn="l" marL="177800" indent="-177800">
+            <a:pPr marL="177800" indent="-177800">
               <a:spcAft>
                 <a:spcPts val="600"/>
               </a:spcAft>
@@ -1749,12 +1959,12 @@
                 <a:ea typeface="Arial" pitchFamily="34" charset="-122"/>
                 <a:cs typeface="Arial" pitchFamily="34" charset="-120"/>
               </a:rPr>
-              <a:t>Capacity lives in spreadsheets, systems and memory</a:t>
+              <a:t>Hard</a:t>
             </a:r>
             <a:endParaRPr lang="en-US" sz="1300" dirty="0"/>
           </a:p>
           <a:p>
-            <a:pPr algn="l" marL="177800" indent="-177800">
+            <a:pPr marL="177800" indent="-177800">
               <a:spcAft>
                 <a:spcPts val="600"/>
               </a:spcAft>
@@ -1770,34 +1980,12 @@
                 <a:ea typeface="Arial" pitchFamily="34" charset="-122"/>
                 <a:cs typeface="Arial" pitchFamily="34" charset="-120"/>
               </a:rPr>
-              <a:t>PCCs re-key the same data across tools</a:t>
+              <a:t>Disjointed</a:t>
             </a:r>
             <a:endParaRPr lang="en-US" sz="1300" dirty="0"/>
           </a:p>
-        </p:txBody>
-      </p:sp>
-      <p:sp>
-        <p:nvSpPr>
-          <p:cNvPr id="20" name="Text 18"/>
-          <p:cNvSpPr txBox="1"/>
-          <p:nvPr/>
-        </p:nvSpPr>
-        <p:spPr>
-          <a:xfrm>
-            <a:off x="812800" y="2095500"/>
-            <a:ext cx="2349500" cy="1333500"/>
-          </a:xfrm>
-          <a:prstGeom prst="rect">
-            <a:avLst/>
-          </a:prstGeom>
-          <a:noFill/>
-          <a:ln/>
-        </p:spPr>
-        <p:txBody>
-          <a:bodyPr wrap="square" lIns="0" tIns="0" rIns="0" bIns="0" rtlCol="0" anchor="ctr"/>
-          <a:lstStyle/>
-          <a:p>
-            <a:pPr algn="l" marL="177800" indent="-177800">
+          <a:p>
+            <a:pPr marL="177800" indent="-177800">
               <a:spcAft>
                 <a:spcPts val="600"/>
               </a:spcAft>
@@ -1813,12 +2001,34 @@
                 <a:ea typeface="Arial" pitchFamily="34" charset="-122"/>
                 <a:cs typeface="Arial" pitchFamily="34" charset="-120"/>
               </a:rPr>
-              <a:t>Capacity by discipline and territory in one view</a:t>
+              <a:t>Complex</a:t>
             </a:r>
             <a:endParaRPr lang="en-US" sz="1300" dirty="0"/>
           </a:p>
-          <a:p>
-            <a:pPr algn="l" marL="177800" indent="-177800">
+        </p:txBody>
+      </p:sp>
+      <p:sp>
+        <p:nvSpPr>
+          <p:cNvPr id="20" name="Text 18"/>
+          <p:cNvSpPr txBox="1"/>
+          <p:nvPr/>
+        </p:nvSpPr>
+        <p:spPr>
+          <a:xfrm>
+            <a:off x="812800" y="2095500"/>
+            <a:ext cx="2235200" cy="1333500"/>
+          </a:xfrm>
+          <a:prstGeom prst="rect">
+            <a:avLst/>
+          </a:prstGeom>
+          <a:noFill/>
+          <a:ln/>
+        </p:spPr>
+        <p:txBody>
+          <a:bodyPr wrap="square" lIns="0" tIns="0" rIns="0" bIns="0" rtlCol="0" anchor="ctr"/>
+          <a:lstStyle/>
+          <a:p>
+            <a:pPr marL="177800" indent="-177800">
               <a:spcAft>
                 <a:spcPts val="600"/>
               </a:spcAft>
@@ -1826,7 +2036,7 @@
               <a:buChar char="•"/>
             </a:pPr>
             <a:r>
-              <a:rPr lang="en-US" sz="1300" dirty="0">
+              <a:rPr lang="en-US" sz="1200" dirty="0">
                 <a:solidFill>
                   <a:srgbClr val="3D4A5C"/>
                 </a:solidFill>
@@ -1834,34 +2044,12 @@
                 <a:ea typeface="Arial" pitchFamily="34" charset="-122"/>
                 <a:cs typeface="Arial" pitchFamily="34" charset="-120"/>
               </a:rPr>
-              <a:t>Automation and recommendations that show their reasoning</a:t>
-            </a:r>
-            <a:endParaRPr lang="en-US" sz="1300" dirty="0"/>
-          </a:p>
-        </p:txBody>
-      </p:sp>
-      <p:sp>
-        <p:nvSpPr>
-          <p:cNvPr id="21" name="Text 19"/>
-          <p:cNvSpPr txBox="1"/>
-          <p:nvPr/>
-        </p:nvSpPr>
-        <p:spPr>
-          <a:xfrm>
-            <a:off x="9017000" y="2095500"/>
-            <a:ext cx="2362200" cy="1333500"/>
-          </a:xfrm>
-          <a:prstGeom prst="rect">
-            <a:avLst/>
-          </a:prstGeom>
-          <a:noFill/>
-          <a:ln/>
-        </p:spPr>
-        <p:txBody>
-          <a:bodyPr wrap="square" lIns="0" tIns="0" rIns="0" bIns="0" rtlCol="0" anchor="ctr"/>
-          <a:lstStyle/>
-          <a:p>
-            <a:pPr algn="l" marL="177800" indent="-177800">
+              <a:t>Capacity visible by discipline and territory</a:t>
+            </a:r>
+            <a:endParaRPr lang="en-US" sz="1200" dirty="0"/>
+          </a:p>
+          <a:p>
+            <a:pPr marL="177800" indent="-177800">
               <a:spcAft>
                 <a:spcPts val="600"/>
               </a:spcAft>
@@ -1869,7 +2057,7 @@
               <a:buChar char="•"/>
             </a:pPr>
             <a:r>
-              <a:rPr lang="en-US" sz="1300" dirty="0">
+              <a:rPr lang="en-US" sz="1200" dirty="0">
                 <a:solidFill>
                   <a:srgbClr val="3D4A5C"/>
                 </a:solidFill>
@@ -1877,12 +2065,12 @@
                 <a:ea typeface="Arial" pitchFamily="34" charset="-122"/>
                 <a:cs typeface="Arial" pitchFamily="34" charset="-120"/>
               </a:rPr>
-              <a:t>SMEs test vendors on real scenarios</a:t>
-            </a:r>
-            <a:endParaRPr lang="en-US" sz="1300" dirty="0"/>
-          </a:p>
-          <a:p>
-            <a:pPr algn="l" marL="177800" indent="-177800">
+              <a:t>Repetitive scheduling steps automated</a:t>
+            </a:r>
+            <a:endParaRPr lang="en-US" sz="1200" dirty="0"/>
+          </a:p>
+          <a:p>
+            <a:pPr marL="177800" indent="-177800">
               <a:spcAft>
                 <a:spcPts val="600"/>
               </a:spcAft>
@@ -1890,7 +2078,7 @@
               <a:buChar char="•"/>
             </a:pPr>
             <a:r>
-              <a:rPr lang="en-US" sz="1300" dirty="0">
+              <a:rPr lang="en-US" sz="1200" dirty="0">
                 <a:solidFill>
                   <a:srgbClr val="3D4A5C"/>
                 </a:solidFill>
@@ -1898,22 +2086,22 @@
                 <a:ea typeface="Arial" pitchFamily="34" charset="-122"/>
                 <a:cs typeface="Arial" pitchFamily="34" charset="-120"/>
               </a:rPr>
-              <a:t>Capacity first, then a measured pilot</a:t>
-            </a:r>
-            <a:endParaRPr lang="en-US" sz="1300" dirty="0"/>
-          </a:p>
-        </p:txBody>
-      </p:sp>
-      <p:sp>
-        <p:nvSpPr>
-          <p:cNvPr id="22" name="Text 20"/>
+              <a:t>Recommendations that show their reasoning</a:t>
+            </a:r>
+            <a:endParaRPr lang="en-US" sz="1200" dirty="0"/>
+          </a:p>
+        </p:txBody>
+      </p:sp>
+      <p:sp>
+        <p:nvSpPr>
+          <p:cNvPr id="21" name="Text 19"/>
           <p:cNvSpPr txBox="1"/>
           <p:nvPr/>
         </p:nvSpPr>
         <p:spPr>
           <a:xfrm>
-            <a:off x="9017000" y="4064000"/>
-            <a:ext cx="2362200" cy="1333500"/>
+            <a:off x="9144000" y="2095500"/>
+            <a:ext cx="2235200" cy="1333500"/>
           </a:xfrm>
           <a:prstGeom prst="rect">
             <a:avLst/>
@@ -1925,7 +2113,7 @@
           <a:bodyPr wrap="square" lIns="0" tIns="0" rIns="0" bIns="0" rtlCol="0" anchor="ctr"/>
           <a:lstStyle/>
           <a:p>
-            <a:pPr algn="l" marL="177800" indent="-177800">
+            <a:pPr marL="177800" indent="-177800">
               <a:spcAft>
                 <a:spcPts val="600"/>
               </a:spcAft>
@@ -1933,7 +2121,7 @@
               <a:buChar char="•"/>
             </a:pPr>
             <a:r>
-              <a:rPr lang="en-US" sz="1300" dirty="0">
+              <a:rPr lang="en-US" sz="1200" dirty="0">
                 <a:solidFill>
                   <a:srgbClr val="3D4A5C"/>
                 </a:solidFill>
@@ -1941,12 +2129,12 @@
                 <a:ea typeface="Arial" pitchFamily="34" charset="-122"/>
                 <a:cs typeface="Arial" pitchFamily="34" charset="-120"/>
               </a:rPr>
-              <a:t>Branches say yes to referrals with confidence</a:t>
-            </a:r>
-            <a:endParaRPr lang="en-US" sz="1300" dirty="0"/>
-          </a:p>
-          <a:p>
-            <a:pPr algn="l" marL="177800" indent="-177800">
+              <a:t>Field experts help choose the tool</a:t>
+            </a:r>
+            <a:endParaRPr lang="en-US" sz="1200" dirty="0"/>
+          </a:p>
+          <a:p>
+            <a:pPr marL="177800" indent="-177800">
               <a:spcAft>
                 <a:spcPts val="600"/>
               </a:spcAft>
@@ -1954,7 +2142,7 @@
               <a:buChar char="•"/>
             </a:pPr>
             <a:r>
-              <a:rPr lang="en-US" sz="1300" dirty="0">
+              <a:rPr lang="en-US" sz="1200" dirty="0">
                 <a:solidFill>
                   <a:srgbClr val="3D4A5C"/>
                 </a:solidFill>
@@ -1962,7 +2150,113 @@
                 <a:ea typeface="Arial" pitchFamily="34" charset="-122"/>
                 <a:cs typeface="Arial" pitchFamily="34" charset="-120"/>
               </a:rPr>
-              <a:t>PCCs and clinicians get time back every day</a:t>
+              <a:t>Flexibility and continuity protected</a:t>
+            </a:r>
+            <a:endParaRPr lang="en-US" sz="1200" dirty="0"/>
+          </a:p>
+          <a:p>
+            <a:pPr marL="177800" indent="-177800">
+              <a:spcAft>
+                <a:spcPts val="600"/>
+              </a:spcAft>
+              <a:buSzPct val="100000"/>
+              <a:buChar char="•"/>
+            </a:pPr>
+            <a:r>
+              <a:rPr lang="en-US" sz="1200" dirty="0">
+                <a:solidFill>
+                  <a:srgbClr val="3D4A5C"/>
+                </a:solidFill>
+                <a:latin typeface="Arial" pitchFamily="34" charset="0"/>
+                <a:ea typeface="Arial" pitchFamily="34" charset="-122"/>
+                <a:cs typeface="Arial" pitchFamily="34" charset="-120"/>
+              </a:rPr>
+              <a:t>Capacity first, then a measured pilot before scaling</a:t>
+            </a:r>
+            <a:endParaRPr lang="en-US" sz="1200" dirty="0"/>
+          </a:p>
+        </p:txBody>
+      </p:sp>
+      <p:sp>
+        <p:nvSpPr>
+          <p:cNvPr id="22" name="Text 20"/>
+          <p:cNvSpPr txBox="1"/>
+          <p:nvPr/>
+        </p:nvSpPr>
+        <p:spPr>
+          <a:xfrm>
+            <a:off x="9144000" y="4127500"/>
+            <a:ext cx="2235200" cy="1333500"/>
+          </a:xfrm>
+          <a:prstGeom prst="rect">
+            <a:avLst/>
+          </a:prstGeom>
+          <a:noFill/>
+          <a:ln/>
+        </p:spPr>
+        <p:txBody>
+          <a:bodyPr wrap="square" lIns="0" tIns="0" rIns="0" bIns="0" rtlCol="0" anchor="ctr"/>
+          <a:lstStyle/>
+          <a:p>
+            <a:pPr marL="177800" indent="-177800">
+              <a:spcAft>
+                <a:spcPts val="600"/>
+              </a:spcAft>
+              <a:buSzPct val="100000"/>
+              <a:buChar char="•"/>
+            </a:pPr>
+            <a:r>
+              <a:rPr lang="en-US" sz="1300" dirty="0">
+                <a:solidFill>
+                  <a:srgbClr val="3D4A5C"/>
+                </a:solidFill>
+                <a:latin typeface="Arial" pitchFamily="34" charset="0"/>
+                <a:ea typeface="Arial" pitchFamily="34" charset="-122"/>
+                <a:cs typeface="Arial" pitchFamily="34" charset="-120"/>
+              </a:rPr>
+              <a:t>Business growth</a:t>
+            </a:r>
+            <a:endParaRPr lang="en-US" sz="1300" dirty="0"/>
+          </a:p>
+          <a:p>
+            <a:pPr marL="177800" indent="-177800">
+              <a:spcAft>
+                <a:spcPts val="600"/>
+              </a:spcAft>
+              <a:buSzPct val="100000"/>
+              <a:buChar char="•"/>
+            </a:pPr>
+            <a:r>
+              <a:rPr lang="en-US" sz="1300" dirty="0">
+                <a:solidFill>
+                  <a:srgbClr val="3D4A5C"/>
+                </a:solidFill>
+                <a:latin typeface="Arial" pitchFamily="34" charset="0"/>
+                <a:ea typeface="Arial" pitchFamily="34" charset="-122"/>
+                <a:cs typeface="Arial" pitchFamily="34" charset="-120"/>
+              </a:rPr>
+              <a:t>Employee retention</a:t>
+            </a:r>
+            <a:endParaRPr lang="en-US" sz="1300" dirty="0"/>
+          </a:p>
+          <a:p>
+            <a:pPr marL="177800" indent="-177800">
+              <a:spcAft>
+                <a:spcPts val="600"/>
+              </a:spcAft>
+              <a:buSzPct val="100000"/>
+              <a:buChar char="•"/>
+            </a:pPr>
+            <a:r>
+              <a:rPr lang="en-US" sz="1300" dirty="0">
+                <a:solidFill>
+                  <a:srgbClr val="3D4A5C"/>
+                </a:solidFill>
+                <a:latin typeface="Arial" pitchFamily="34" charset="0"/>
+                <a:ea typeface="Arial" pitchFamily="34" charset="-122"/>
+                <a:cs typeface="Arial" pitchFamily="34" charset="-120"/>
+              </a:rPr>
+              <a:t>Patients served</a:t>
             </a:r>
             <a:endParaRPr lang="en-US" sz="1300" dirty="0"/>
           </a:p>
@@ -2011,6 +2305,1661 @@
             <a:fld id="{F7021451-1387-4CA6-816F-3879F97B5CBC}" type="slidenum">
               <a:rPr b="0" lang="en-US"/>
               <a:t>1</a:t>
+            </a:fld>
+            <a:endParaRPr lang="en-US"/>
+          </a:p>
+        </p:txBody>
+      </p:sp>
+    </p:spTree>
+  </p:cSld>
+  <p:clrMapOvr>
+    <a:masterClrMapping/>
+  </p:clrMapOvr>
+</p:sld>
+</file>
+
+<file path=ppt/slides/slide2.xml><?xml version="1.0" encoding="utf-8"?>
+<p:sld xmlns:a="http://schemas.openxmlformats.org/drawingml/2006/main" xmlns:r="http://schemas.openxmlformats.org/officeDocument/2006/relationships" xmlns:p="http://schemas.openxmlformats.org/presentationml/2006/main">
+  <p:cSld name="Slide 2">
+    <p:spTree>
+      <p:nvGrpSpPr>
+        <p:cNvPr id="1" name=""/>
+        <p:cNvGrpSpPr/>
+        <p:nvPr/>
+      </p:nvGrpSpPr>
+      <p:grpSpPr>
+        <a:xfrm>
+          <a:off x="0" y="0"/>
+          <a:ext cx="0" cy="0"/>
+          <a:chOff x="0" y="0"/>
+          <a:chExt cx="0" cy="0"/>
+        </a:xfrm>
+      </p:grpSpPr>
+      <p:sp>
+        <p:nvSpPr>
+          <p:cNvPr id="2" name="Text 1"/>
+          <p:cNvSpPr/>
+          <p:nvPr>
+            <p:ph idx="102" type="body" hasCustomPrompt="1"/>
+          </p:nvPr>
+        </p:nvSpPr>
+        <p:spPr>
+          <a:xfrm>
+            <a:off x="812800" y="812800"/>
+            <a:ext cx="10566400" cy="254000"/>
+          </a:xfrm>
+          <a:prstGeom prst="rect">
+            <a:avLst/>
+          </a:prstGeom>
+          <a:noFill/>
+          <a:ln/>
+        </p:spPr>
+        <p:txBody>
+          <a:bodyPr wrap="square" lIns="0" tIns="0" rIns="0" bIns="0" rtlCol="0" anchor="t"/>
+          <a:lstStyle/>
+          <a:p>
+            <a:pPr indent="0" marL="0">
+              <a:buNone/>
+            </a:pPr>
+            <a:r>
+              <a:rPr lang="en-US" sz="1200" b="1" spc="200" kern="0" dirty="0">
+                <a:solidFill>
+                  <a:srgbClr val="8A5F00"/>
+                </a:solidFill>
+                <a:latin typeface="Arial" pitchFamily="34" charset="0"/>
+                <a:ea typeface="Arial" pitchFamily="34" charset="-122"/>
+                <a:cs typeface="Arial" pitchFamily="34" charset="-120"/>
+              </a:rPr>
+              <a:t>MESSAGE FRAME · WHAT IT MEANS</a:t>
+            </a:r>
+            <a:endParaRPr lang="en-US" sz="1200" dirty="0"/>
+          </a:p>
+        </p:txBody>
+      </p:sp>
+      <p:sp>
+        <p:nvSpPr>
+          <p:cNvPr id="3" name="Text 1"/>
+          <p:cNvSpPr/>
+          <p:nvPr>
+            <p:ph idx="103" type="title" hasCustomPrompt="1"/>
+          </p:nvPr>
+        </p:nvSpPr>
+        <p:spPr>
+          <a:xfrm>
+            <a:off x="812800" y="1117600"/>
+            <a:ext cx="10566400" cy="635000"/>
+          </a:xfrm>
+          <a:prstGeom prst="rect">
+            <a:avLst/>
+          </a:prstGeom>
+          <a:noFill/>
+          <a:ln/>
+        </p:spPr>
+        <p:txBody>
+          <a:bodyPr wrap="square" lIns="0" tIns="0" rIns="0" bIns="0" rtlCol="0" anchor="t"/>
+          <a:lstStyle/>
+          <a:p>
+            <a:pPr algn="l" indent="0" marL="0">
+              <a:buNone/>
+            </a:pPr>
+            <a:r>
+              <a:rPr lang="en-US" sz="4000" dirty="0">
+                <a:solidFill>
+                  <a:srgbClr val="002554"/>
+                </a:solidFill>
+                <a:latin typeface="Maven Pro" pitchFamily="34" charset="0"/>
+                <a:ea typeface="Maven Pro" pitchFamily="34" charset="-122"/>
+                <a:cs typeface="Maven Pro" pitchFamily="34" charset="-120"/>
+              </a:rPr>
+              <a:t>From hard decisions to growth</a:t>
+            </a:r>
+            <a:endParaRPr lang="en-US" sz="4000" dirty="0"/>
+          </a:p>
+        </p:txBody>
+      </p:sp>
+      <p:sp>
+        <p:nvSpPr>
+          <p:cNvPr id="4" name="Shape 2"/>
+          <p:cNvSpPr/>
+          <p:nvPr/>
+        </p:nvSpPr>
+        <p:spPr>
+          <a:xfrm>
+            <a:off x="812800" y="1905000"/>
+            <a:ext cx="2527300" cy="3873500"/>
+          </a:xfrm>
+          <a:prstGeom prst="rect">
+            <a:avLst/>
+          </a:prstGeom>
+          <a:solidFill>
+            <a:srgbClr val="002554"/>
+          </a:solidFill>
+          <a:ln w="9525">
+            <a:solidFill>
+              <a:srgbClr val="002554"/>
+            </a:solidFill>
+            <a:prstDash val="solid"/>
+          </a:ln>
+        </p:spPr>
+      </p:sp>
+      <p:sp>
+        <p:nvSpPr>
+          <p:cNvPr id="5" name="Text 3"/>
+          <p:cNvSpPr txBox="1"/>
+          <p:nvPr/>
+        </p:nvSpPr>
+        <p:spPr>
+          <a:xfrm>
+            <a:off x="1041400" y="2108200"/>
+            <a:ext cx="2070100" cy="177800"/>
+          </a:xfrm>
+          <a:prstGeom prst="rect">
+            <a:avLst/>
+          </a:prstGeom>
+          <a:noFill/>
+          <a:ln/>
+        </p:spPr>
+        <p:txBody>
+          <a:bodyPr wrap="square" lIns="0" tIns="0" rIns="0" bIns="0" rtlCol="0" anchor="t"/>
+          <a:lstStyle/>
+          <a:p>
+            <a:pPr algn="l" indent="0" marL="0">
+              <a:buNone/>
+            </a:pPr>
+            <a:r>
+              <a:rPr lang="en-US" sz="1050" b="1" spc="150" kern="0" dirty="0">
+                <a:solidFill>
+                  <a:srgbClr val="9AAAC0"/>
+                </a:solidFill>
+                <a:latin typeface="Arial" pitchFamily="34" charset="0"/>
+                <a:ea typeface="Arial" pitchFamily="34" charset="-122"/>
+                <a:cs typeface="Arial" pitchFamily="34" charset="-120"/>
+              </a:rPr>
+              <a:t>PROBLEM</a:t>
+            </a:r>
+            <a:endParaRPr lang="en-US" sz="1050" dirty="0"/>
+          </a:p>
+        </p:txBody>
+      </p:sp>
+      <p:sp>
+        <p:nvSpPr>
+          <p:cNvPr id="6" name="Text 4"/>
+          <p:cNvSpPr txBox="1"/>
+          <p:nvPr/>
+        </p:nvSpPr>
+        <p:spPr>
+          <a:xfrm>
+            <a:off x="1041400" y="2311400"/>
+            <a:ext cx="2070100" cy="190500"/>
+          </a:xfrm>
+          <a:prstGeom prst="rect">
+            <a:avLst/>
+          </a:prstGeom>
+          <a:noFill/>
+          <a:ln/>
+        </p:spPr>
+        <p:txBody>
+          <a:bodyPr wrap="square" lIns="0" tIns="0" rIns="0" bIns="0" rtlCol="0" anchor="t"/>
+          <a:lstStyle/>
+          <a:p>
+            <a:pPr algn="l" indent="0" marL="0">
+              <a:buNone/>
+            </a:pPr>
+            <a:r>
+              <a:rPr lang="en-US" sz="1300" dirty="0">
+                <a:solidFill>
+                  <a:srgbClr val="C9D3E0"/>
+                </a:solidFill>
+                <a:latin typeface="Arial" pitchFamily="34" charset="0"/>
+                <a:ea typeface="Arial" pitchFamily="34" charset="-122"/>
+                <a:cs typeface="Arial" pitchFamily="34" charset="-120"/>
+              </a:rPr>
+              <a:t>Today, every branch runs on</a:t>
+            </a:r>
+            <a:endParaRPr lang="en-US" sz="1300" dirty="0"/>
+          </a:p>
+        </p:txBody>
+      </p:sp>
+      <p:sp>
+        <p:nvSpPr>
+          <p:cNvPr id="7" name="Text 5"/>
+          <p:cNvSpPr txBox="1"/>
+          <p:nvPr/>
+        </p:nvSpPr>
+        <p:spPr>
+          <a:xfrm>
+            <a:off x="1041400" y="2540000"/>
+            <a:ext cx="2070100" cy="635000"/>
+          </a:xfrm>
+          <a:prstGeom prst="rect">
+            <a:avLst/>
+          </a:prstGeom>
+          <a:noFill/>
+          <a:ln/>
+        </p:spPr>
+        <p:txBody>
+          <a:bodyPr wrap="square" lIns="0" tIns="0" rIns="0" bIns="0" rtlCol="0" anchor="ctr"/>
+          <a:lstStyle/>
+          <a:p>
+            <a:pPr algn="l" indent="0" marL="0">
+              <a:lnSpc>
+                <a:spcPct val="95000"/>
+              </a:lnSpc>
+              <a:buNone/>
+            </a:pPr>
+            <a:r>
+              <a:rPr lang="en-US" sz="2600" b="1" dirty="0">
+                <a:solidFill>
+                  <a:srgbClr val="CE8E00"/>
+                </a:solidFill>
+                <a:latin typeface="Maven Pro" pitchFamily="34" charset="0"/>
+                <a:ea typeface="Maven Pro" pitchFamily="34" charset="-122"/>
+                <a:cs typeface="Maven Pro" pitchFamily="34" charset="-120"/>
+              </a:rPr>
+              <a:t>DECISIONS</a:t>
+            </a:r>
+            <a:endParaRPr lang="en-US" sz="2600" dirty="0"/>
+          </a:p>
+        </p:txBody>
+      </p:sp>
+      <p:sp>
+        <p:nvSpPr>
+          <p:cNvPr id="8" name="Shape 6"/>
+          <p:cNvSpPr/>
+          <p:nvPr/>
+        </p:nvSpPr>
+        <p:spPr>
+          <a:xfrm>
+            <a:off x="1041400" y="3302000"/>
+            <a:ext cx="2070100" cy="0"/>
+          </a:xfrm>
+          <a:prstGeom prst="line">
+            <a:avLst/>
+          </a:prstGeom>
+          <a:noFill/>
+          <a:ln w="19050">
+            <a:solidFill>
+              <a:srgbClr val="2A4A78"/>
+            </a:solidFill>
+            <a:prstDash val="solid"/>
+          </a:ln>
+        </p:spPr>
+      </p:sp>
+      <p:sp>
+        <p:nvSpPr>
+          <p:cNvPr id="9" name="Text 7"/>
+          <p:cNvSpPr txBox="1"/>
+          <p:nvPr/>
+        </p:nvSpPr>
+        <p:spPr>
+          <a:xfrm>
+            <a:off x="1041400" y="3479800"/>
+            <a:ext cx="2070100" cy="2095500"/>
+          </a:xfrm>
+          <a:prstGeom prst="rect">
+            <a:avLst/>
+          </a:prstGeom>
+          <a:noFill/>
+          <a:ln/>
+        </p:spPr>
+        <p:txBody>
+          <a:bodyPr wrap="square" lIns="0" tIns="0" rIns="0" bIns="0" rtlCol="0" anchor="t"/>
+          <a:lstStyle/>
+          <a:p>
+            <a:pPr marL="177800" indent="-177800">
+              <a:spcAft>
+                <a:spcPts val="600"/>
+              </a:spcAft>
+              <a:buSzPct val="100000"/>
+              <a:buChar char="•"/>
+            </a:pPr>
+            <a:r>
+              <a:rPr lang="en-US" sz="1250" dirty="0">
+                <a:solidFill>
+                  <a:srgbClr val="C9D3E0"/>
+                </a:solidFill>
+                <a:latin typeface="Arial" pitchFamily="34" charset="0"/>
+                <a:ea typeface="Arial" pitchFamily="34" charset="-122"/>
+                <a:cs typeface="Arial" pitchFamily="34" charset="-120"/>
+              </a:rPr>
+              <a:t>Hard: too many visits, windows, authorizations and territories to weigh by hand</a:t>
+            </a:r>
+            <a:endParaRPr lang="en-US" sz="1250" dirty="0"/>
+          </a:p>
+          <a:p>
+            <a:pPr marL="177800" indent="-177800">
+              <a:spcAft>
+                <a:spcPts val="600"/>
+              </a:spcAft>
+              <a:buSzPct val="100000"/>
+              <a:buChar char="•"/>
+            </a:pPr>
+            <a:r>
+              <a:rPr lang="en-US" sz="1250" dirty="0">
+                <a:solidFill>
+                  <a:srgbClr val="C9D3E0"/>
+                </a:solidFill>
+                <a:latin typeface="Arial" pitchFamily="34" charset="0"/>
+                <a:ea typeface="Arial" pitchFamily="34" charset="-122"/>
+                <a:cs typeface="Arial" pitchFamily="34" charset="-120"/>
+              </a:rPr>
+              <a:t>Disjointed: spread across HCHB, spreadsheets, Workday and memory</a:t>
+            </a:r>
+            <a:endParaRPr lang="en-US" sz="1250" dirty="0"/>
+          </a:p>
+          <a:p>
+            <a:pPr marL="177800" indent="-177800">
+              <a:spcAft>
+                <a:spcPts val="600"/>
+              </a:spcAft>
+              <a:buSzPct val="100000"/>
+              <a:buChar char="•"/>
+            </a:pPr>
+            <a:r>
+              <a:rPr lang="en-US" sz="1250" dirty="0">
+                <a:solidFill>
+                  <a:srgbClr val="C9D3E0"/>
+                </a:solidFill>
+                <a:latin typeface="Arial" pitchFamily="34" charset="0"/>
+                <a:ea typeface="Arial" pitchFamily="34" charset="-122"/>
+                <a:cs typeface="Arial" pitchFamily="34" charset="-120"/>
+              </a:rPr>
+              <a:t>Complex: every choice ripples across patients, clinicians and compliance</a:t>
+            </a:r>
+            <a:endParaRPr lang="en-US" sz="1250" dirty="0"/>
+          </a:p>
+        </p:txBody>
+      </p:sp>
+      <p:sp>
+        <p:nvSpPr>
+          <p:cNvPr id="10" name="Shape 8"/>
+          <p:cNvSpPr/>
+          <p:nvPr/>
+        </p:nvSpPr>
+        <p:spPr>
+          <a:xfrm>
+            <a:off x="3492500" y="1905000"/>
+            <a:ext cx="2527300" cy="3873500"/>
+          </a:xfrm>
+          <a:prstGeom prst="rect">
+            <a:avLst/>
+          </a:prstGeom>
+          <a:solidFill>
+            <a:srgbClr val="FDFCFA"/>
+          </a:solidFill>
+          <a:ln w="9525">
+            <a:solidFill>
+              <a:srgbClr val="E3DED3"/>
+            </a:solidFill>
+            <a:prstDash val="solid"/>
+          </a:ln>
+        </p:spPr>
+      </p:sp>
+      <p:sp>
+        <p:nvSpPr>
+          <p:cNvPr id="11" name="Text 9"/>
+          <p:cNvSpPr txBox="1"/>
+          <p:nvPr/>
+        </p:nvSpPr>
+        <p:spPr>
+          <a:xfrm>
+            <a:off x="3721100" y="2108200"/>
+            <a:ext cx="2070100" cy="177800"/>
+          </a:xfrm>
+          <a:prstGeom prst="rect">
+            <a:avLst/>
+          </a:prstGeom>
+          <a:noFill/>
+          <a:ln/>
+        </p:spPr>
+        <p:txBody>
+          <a:bodyPr wrap="square" lIns="0" tIns="0" rIns="0" bIns="0" rtlCol="0" anchor="t"/>
+          <a:lstStyle/>
+          <a:p>
+            <a:pPr algn="l" indent="0" marL="0">
+              <a:buNone/>
+            </a:pPr>
+            <a:r>
+              <a:rPr lang="en-US" sz="1050" b="1" spc="150" kern="0" dirty="0">
+                <a:solidFill>
+                  <a:srgbClr val="5A6472"/>
+                </a:solidFill>
+                <a:latin typeface="Arial" pitchFamily="34" charset="0"/>
+                <a:ea typeface="Arial" pitchFamily="34" charset="-122"/>
+                <a:cs typeface="Arial" pitchFamily="34" charset="-120"/>
+              </a:rPr>
+              <a:t>SOLUTION</a:t>
+            </a:r>
+            <a:endParaRPr lang="en-US" sz="1050" dirty="0"/>
+          </a:p>
+        </p:txBody>
+      </p:sp>
+      <p:sp>
+        <p:nvSpPr>
+          <p:cNvPr id="12" name="Text 10"/>
+          <p:cNvSpPr txBox="1"/>
+          <p:nvPr/>
+        </p:nvSpPr>
+        <p:spPr>
+          <a:xfrm>
+            <a:off x="3721100" y="2311400"/>
+            <a:ext cx="2070100" cy="190500"/>
+          </a:xfrm>
+          <a:prstGeom prst="rect">
+            <a:avLst/>
+          </a:prstGeom>
+          <a:noFill/>
+          <a:ln/>
+        </p:spPr>
+        <p:txBody>
+          <a:bodyPr wrap="square" lIns="0" tIns="0" rIns="0" bIns="0" rtlCol="0" anchor="t"/>
+          <a:lstStyle/>
+          <a:p>
+            <a:pPr algn="l" indent="0" marL="0">
+              <a:buNone/>
+            </a:pPr>
+            <a:r>
+              <a:rPr lang="en-US" sz="1300" dirty="0">
+                <a:solidFill>
+                  <a:srgbClr val="3D4A5C"/>
+                </a:solidFill>
+                <a:latin typeface="Arial" pitchFamily="34" charset="0"/>
+                <a:ea typeface="Arial" pitchFamily="34" charset="-122"/>
+                <a:cs typeface="Arial" pitchFamily="34" charset="-120"/>
+              </a:rPr>
+              <a:t>Our solution must be</a:t>
+            </a:r>
+            <a:endParaRPr lang="en-US" sz="1300" dirty="0"/>
+          </a:p>
+        </p:txBody>
+      </p:sp>
+      <p:sp>
+        <p:nvSpPr>
+          <p:cNvPr id="13" name="Text 11"/>
+          <p:cNvSpPr txBox="1"/>
+          <p:nvPr/>
+        </p:nvSpPr>
+        <p:spPr>
+          <a:xfrm>
+            <a:off x="3721100" y="2540000"/>
+            <a:ext cx="2070100" cy="635000"/>
+          </a:xfrm>
+          <a:prstGeom prst="rect">
+            <a:avLst/>
+          </a:prstGeom>
+          <a:noFill/>
+          <a:ln/>
+        </p:spPr>
+        <p:txBody>
+          <a:bodyPr wrap="square" lIns="0" tIns="0" rIns="0" bIns="0" rtlCol="0" anchor="ctr"/>
+          <a:lstStyle/>
+          <a:p>
+            <a:pPr algn="l" indent="0" marL="0">
+              <a:lnSpc>
+                <a:spcPct val="95000"/>
+              </a:lnSpc>
+              <a:buNone/>
+            </a:pPr>
+            <a:r>
+              <a:rPr lang="en-US" sz="2600" b="1" dirty="0">
+                <a:solidFill>
+                  <a:srgbClr val="002554"/>
+                </a:solidFill>
+                <a:latin typeface="Maven Pro" pitchFamily="34" charset="0"/>
+                <a:ea typeface="Maven Pro" pitchFamily="34" charset="-122"/>
+                <a:cs typeface="Maven Pro" pitchFamily="34" charset="-120"/>
+              </a:rPr>
+              <a:t>OPTIMIZED</a:t>
+            </a:r>
+            <a:endParaRPr lang="en-US" sz="2600" dirty="0"/>
+          </a:p>
+        </p:txBody>
+      </p:sp>
+      <p:sp>
+        <p:nvSpPr>
+          <p:cNvPr id="14" name="Shape 12"/>
+          <p:cNvSpPr/>
+          <p:nvPr/>
+        </p:nvSpPr>
+        <p:spPr>
+          <a:xfrm>
+            <a:off x="3721100" y="3302000"/>
+            <a:ext cx="2070100" cy="0"/>
+          </a:xfrm>
+          <a:prstGeom prst="line">
+            <a:avLst/>
+          </a:prstGeom>
+          <a:noFill/>
+          <a:ln w="19050">
+            <a:solidFill>
+              <a:srgbClr val="D6D0C2"/>
+            </a:solidFill>
+            <a:prstDash val="solid"/>
+          </a:ln>
+        </p:spPr>
+      </p:sp>
+      <p:sp>
+        <p:nvSpPr>
+          <p:cNvPr id="15" name="Text 13"/>
+          <p:cNvSpPr txBox="1"/>
+          <p:nvPr/>
+        </p:nvSpPr>
+        <p:spPr>
+          <a:xfrm>
+            <a:off x="3721100" y="3479800"/>
+            <a:ext cx="2070100" cy="2095500"/>
+          </a:xfrm>
+          <a:prstGeom prst="rect">
+            <a:avLst/>
+          </a:prstGeom>
+          <a:noFill/>
+          <a:ln/>
+        </p:spPr>
+        <p:txBody>
+          <a:bodyPr wrap="square" lIns="0" tIns="0" rIns="0" bIns="0" rtlCol="0" anchor="t"/>
+          <a:lstStyle/>
+          <a:p>
+            <a:pPr marL="177800" indent="-177800">
+              <a:spcAft>
+                <a:spcPts val="600"/>
+              </a:spcAft>
+              <a:buSzPct val="100000"/>
+              <a:buChar char="•"/>
+            </a:pPr>
+            <a:r>
+              <a:rPr lang="en-US" sz="1250" dirty="0">
+                <a:solidFill>
+                  <a:srgbClr val="3D4A5C"/>
+                </a:solidFill>
+                <a:latin typeface="Arial" pitchFamily="34" charset="0"/>
+                <a:ea typeface="Arial" pitchFamily="34" charset="-122"/>
+                <a:cs typeface="Arial" pitchFamily="34" charset="-120"/>
+              </a:rPr>
+              <a:t>Capacity visible by discipline and territory</a:t>
+            </a:r>
+            <a:endParaRPr lang="en-US" sz="1250" dirty="0"/>
+          </a:p>
+          <a:p>
+            <a:pPr marL="177800" indent="-177800">
+              <a:spcAft>
+                <a:spcPts val="600"/>
+              </a:spcAft>
+              <a:buSzPct val="100000"/>
+              <a:buChar char="•"/>
+            </a:pPr>
+            <a:r>
+              <a:rPr lang="en-US" sz="1250" dirty="0">
+                <a:solidFill>
+                  <a:srgbClr val="3D4A5C"/>
+                </a:solidFill>
+                <a:latin typeface="Arial" pitchFamily="34" charset="0"/>
+                <a:ea typeface="Arial" pitchFamily="34" charset="-122"/>
+                <a:cs typeface="Arial" pitchFamily="34" charset="-120"/>
+              </a:rPr>
+              <a:t>Repetitive scheduling steps automated</a:t>
+            </a:r>
+            <a:endParaRPr lang="en-US" sz="1250" dirty="0"/>
+          </a:p>
+          <a:p>
+            <a:pPr marL="177800" indent="-177800">
+              <a:spcAft>
+                <a:spcPts val="600"/>
+              </a:spcAft>
+              <a:buSzPct val="100000"/>
+              <a:buChar char="•"/>
+            </a:pPr>
+            <a:r>
+              <a:rPr lang="en-US" sz="1250" dirty="0">
+                <a:solidFill>
+                  <a:srgbClr val="3D4A5C"/>
+                </a:solidFill>
+                <a:latin typeface="Arial" pitchFamily="34" charset="0"/>
+                <a:ea typeface="Arial" pitchFamily="34" charset="-122"/>
+                <a:cs typeface="Arial" pitchFamily="34" charset="-120"/>
+              </a:rPr>
+              <a:t>Recommendations that show their reasoning</a:t>
+            </a:r>
+            <a:endParaRPr lang="en-US" sz="1250" dirty="0"/>
+          </a:p>
+        </p:txBody>
+      </p:sp>
+      <p:sp>
+        <p:nvSpPr>
+          <p:cNvPr id="16" name="Shape 14"/>
+          <p:cNvSpPr/>
+          <p:nvPr/>
+        </p:nvSpPr>
+        <p:spPr>
+          <a:xfrm>
+            <a:off x="6172200" y="1905000"/>
+            <a:ext cx="2527300" cy="3873500"/>
+          </a:xfrm>
+          <a:prstGeom prst="rect">
+            <a:avLst/>
+          </a:prstGeom>
+          <a:solidFill>
+            <a:srgbClr val="002554"/>
+          </a:solidFill>
+          <a:ln w="9525">
+            <a:solidFill>
+              <a:srgbClr val="002554"/>
+            </a:solidFill>
+            <a:prstDash val="solid"/>
+          </a:ln>
+        </p:spPr>
+      </p:sp>
+      <p:sp>
+        <p:nvSpPr>
+          <p:cNvPr id="17" name="Text 15"/>
+          <p:cNvSpPr txBox="1"/>
+          <p:nvPr/>
+        </p:nvSpPr>
+        <p:spPr>
+          <a:xfrm>
+            <a:off x="6400800" y="2108200"/>
+            <a:ext cx="2070100" cy="177800"/>
+          </a:xfrm>
+          <a:prstGeom prst="rect">
+            <a:avLst/>
+          </a:prstGeom>
+          <a:noFill/>
+          <a:ln/>
+        </p:spPr>
+        <p:txBody>
+          <a:bodyPr wrap="square" lIns="0" tIns="0" rIns="0" bIns="0" rtlCol="0" anchor="t"/>
+          <a:lstStyle/>
+          <a:p>
+            <a:pPr algn="l" indent="0" marL="0">
+              <a:buNone/>
+            </a:pPr>
+            <a:r>
+              <a:rPr lang="en-US" sz="1050" b="1" spc="150" kern="0" dirty="0">
+                <a:solidFill>
+                  <a:srgbClr val="9AAAC0"/>
+                </a:solidFill>
+                <a:latin typeface="Arial" pitchFamily="34" charset="0"/>
+                <a:ea typeface="Arial" pitchFamily="34" charset="-122"/>
+                <a:cs typeface="Arial" pitchFamily="34" charset="-120"/>
+              </a:rPr>
+              <a:t>APPROACH</a:t>
+            </a:r>
+            <a:endParaRPr lang="en-US" sz="1050" dirty="0"/>
+          </a:p>
+        </p:txBody>
+      </p:sp>
+      <p:sp>
+        <p:nvSpPr>
+          <p:cNvPr id="18" name="Text 16"/>
+          <p:cNvSpPr txBox="1"/>
+          <p:nvPr/>
+        </p:nvSpPr>
+        <p:spPr>
+          <a:xfrm>
+            <a:off x="6400800" y="2311400"/>
+            <a:ext cx="2070100" cy="190500"/>
+          </a:xfrm>
+          <a:prstGeom prst="rect">
+            <a:avLst/>
+          </a:prstGeom>
+          <a:noFill/>
+          <a:ln/>
+        </p:spPr>
+        <p:txBody>
+          <a:bodyPr wrap="square" lIns="0" tIns="0" rIns="0" bIns="0" rtlCol="0" anchor="t"/>
+          <a:lstStyle/>
+          <a:p>
+            <a:pPr algn="l" indent="0" marL="0">
+              <a:buNone/>
+            </a:pPr>
+            <a:r>
+              <a:rPr lang="en-US" sz="1300" dirty="0">
+                <a:solidFill>
+                  <a:srgbClr val="C9D3E0"/>
+                </a:solidFill>
+                <a:latin typeface="Arial" pitchFamily="34" charset="0"/>
+                <a:ea typeface="Arial" pitchFamily="34" charset="-122"/>
+                <a:cs typeface="Arial" pitchFamily="34" charset="-120"/>
+              </a:rPr>
+              <a:t>Our approach is</a:t>
+            </a:r>
+            <a:endParaRPr lang="en-US" sz="1300" dirty="0"/>
+          </a:p>
+        </p:txBody>
+      </p:sp>
+      <p:sp>
+        <p:nvSpPr>
+          <p:cNvPr id="19" name="Text 17"/>
+          <p:cNvSpPr txBox="1"/>
+          <p:nvPr/>
+        </p:nvSpPr>
+        <p:spPr>
+          <a:xfrm>
+            <a:off x="6400800" y="2540000"/>
+            <a:ext cx="2070100" cy="635000"/>
+          </a:xfrm>
+          <a:prstGeom prst="rect">
+            <a:avLst/>
+          </a:prstGeom>
+          <a:noFill/>
+          <a:ln/>
+        </p:spPr>
+        <p:txBody>
+          <a:bodyPr wrap="square" lIns="0" tIns="0" rIns="0" bIns="0" rtlCol="0" anchor="ctr"/>
+          <a:lstStyle/>
+          <a:p>
+            <a:pPr algn="l" indent="0" marL="0">
+              <a:lnSpc>
+                <a:spcPct val="95000"/>
+              </a:lnSpc>
+              <a:buNone/>
+            </a:pPr>
+            <a:r>
+              <a:rPr lang="en-US" sz="2200" b="1" dirty="0">
+                <a:solidFill>
+                  <a:srgbClr val="CE8E00"/>
+                </a:solidFill>
+                <a:latin typeface="Maven Pro" pitchFamily="34" charset="0"/>
+                <a:ea typeface="Maven Pro" pitchFamily="34" charset="-122"/>
+                <a:cs typeface="Maven Pro" pitchFamily="34" charset="-120"/>
+              </a:rPr>
+              <a:t>CLINICIAN-</a:t>
+            </a:r>
+            <a:endParaRPr lang="en-US" sz="2200" dirty="0"/>
+          </a:p>
+          <a:p>
+            <a:pPr algn="l" indent="0" marL="0">
+              <a:lnSpc>
+                <a:spcPct val="95000"/>
+              </a:lnSpc>
+              <a:buNone/>
+            </a:pPr>
+            <a:r>
+              <a:rPr lang="en-US" sz="2200" b="1" dirty="0">
+                <a:solidFill>
+                  <a:srgbClr val="CE8E00"/>
+                </a:solidFill>
+                <a:latin typeface="Maven Pro" pitchFamily="34" charset="0"/>
+                <a:ea typeface="Maven Pro" pitchFamily="34" charset="-122"/>
+                <a:cs typeface="Maven Pro" pitchFamily="34" charset="-120"/>
+              </a:rPr>
+              <a:t>CENTERED</a:t>
+            </a:r>
+            <a:endParaRPr lang="en-US" sz="2200" dirty="0"/>
+          </a:p>
+        </p:txBody>
+      </p:sp>
+      <p:sp>
+        <p:nvSpPr>
+          <p:cNvPr id="20" name="Shape 18"/>
+          <p:cNvSpPr/>
+          <p:nvPr/>
+        </p:nvSpPr>
+        <p:spPr>
+          <a:xfrm>
+            <a:off x="6400800" y="3302000"/>
+            <a:ext cx="2070100" cy="0"/>
+          </a:xfrm>
+          <a:prstGeom prst="line">
+            <a:avLst/>
+          </a:prstGeom>
+          <a:noFill/>
+          <a:ln w="19050">
+            <a:solidFill>
+              <a:srgbClr val="2A4A78"/>
+            </a:solidFill>
+            <a:prstDash val="solid"/>
+          </a:ln>
+        </p:spPr>
+      </p:sp>
+      <p:sp>
+        <p:nvSpPr>
+          <p:cNvPr id="21" name="Text 19"/>
+          <p:cNvSpPr txBox="1"/>
+          <p:nvPr/>
+        </p:nvSpPr>
+        <p:spPr>
+          <a:xfrm>
+            <a:off x="6400800" y="3479800"/>
+            <a:ext cx="2070100" cy="2095500"/>
+          </a:xfrm>
+          <a:prstGeom prst="rect">
+            <a:avLst/>
+          </a:prstGeom>
+          <a:noFill/>
+          <a:ln/>
+        </p:spPr>
+        <p:txBody>
+          <a:bodyPr wrap="square" lIns="0" tIns="0" rIns="0" bIns="0" rtlCol="0" anchor="t"/>
+          <a:lstStyle/>
+          <a:p>
+            <a:pPr marL="177800" indent="-177800">
+              <a:spcAft>
+                <a:spcPts val="600"/>
+              </a:spcAft>
+              <a:buSzPct val="100000"/>
+              <a:buChar char="•"/>
+            </a:pPr>
+            <a:r>
+              <a:rPr lang="en-US" sz="1250" dirty="0">
+                <a:solidFill>
+                  <a:srgbClr val="C9D3E0"/>
+                </a:solidFill>
+                <a:latin typeface="Arial" pitchFamily="34" charset="0"/>
+                <a:ea typeface="Arial" pitchFamily="34" charset="-122"/>
+                <a:cs typeface="Arial" pitchFamily="34" charset="-120"/>
+              </a:rPr>
+              <a:t>Field experts help choose the tool</a:t>
+            </a:r>
+            <a:endParaRPr lang="en-US" sz="1250" dirty="0"/>
+          </a:p>
+          <a:p>
+            <a:pPr marL="177800" indent="-177800">
+              <a:spcAft>
+                <a:spcPts val="600"/>
+              </a:spcAft>
+              <a:buSzPct val="100000"/>
+              <a:buChar char="•"/>
+            </a:pPr>
+            <a:r>
+              <a:rPr lang="en-US" sz="1250" dirty="0">
+                <a:solidFill>
+                  <a:srgbClr val="C9D3E0"/>
+                </a:solidFill>
+                <a:latin typeface="Arial" pitchFamily="34" charset="0"/>
+                <a:ea typeface="Arial" pitchFamily="34" charset="-122"/>
+                <a:cs typeface="Arial" pitchFamily="34" charset="-120"/>
+              </a:rPr>
+              <a:t>Flexibility and continuity protected</a:t>
+            </a:r>
+            <a:endParaRPr lang="en-US" sz="1250" dirty="0"/>
+          </a:p>
+          <a:p>
+            <a:pPr marL="177800" indent="-177800">
+              <a:spcAft>
+                <a:spcPts val="600"/>
+              </a:spcAft>
+              <a:buSzPct val="100000"/>
+              <a:buChar char="•"/>
+            </a:pPr>
+            <a:r>
+              <a:rPr lang="en-US" sz="1250" dirty="0">
+                <a:solidFill>
+                  <a:srgbClr val="C9D3E0"/>
+                </a:solidFill>
+                <a:latin typeface="Arial" pitchFamily="34" charset="0"/>
+                <a:ea typeface="Arial" pitchFamily="34" charset="-122"/>
+                <a:cs typeface="Arial" pitchFamily="34" charset="-120"/>
+              </a:rPr>
+              <a:t>Capacity first, then a measured pilot before scaling</a:t>
+            </a:r>
+            <a:endParaRPr lang="en-US" sz="1250" dirty="0"/>
+          </a:p>
+        </p:txBody>
+      </p:sp>
+      <p:sp>
+        <p:nvSpPr>
+          <p:cNvPr id="22" name="Shape 20"/>
+          <p:cNvSpPr/>
+          <p:nvPr/>
+        </p:nvSpPr>
+        <p:spPr>
+          <a:xfrm>
+            <a:off x="8851900" y="1905000"/>
+            <a:ext cx="2527300" cy="3873500"/>
+          </a:xfrm>
+          <a:prstGeom prst="rect">
+            <a:avLst/>
+          </a:prstGeom>
+          <a:solidFill>
+            <a:srgbClr val="FDFCFA"/>
+          </a:solidFill>
+          <a:ln w="9525">
+            <a:solidFill>
+              <a:srgbClr val="E3DED3"/>
+            </a:solidFill>
+            <a:prstDash val="solid"/>
+          </a:ln>
+        </p:spPr>
+      </p:sp>
+      <p:sp>
+        <p:nvSpPr>
+          <p:cNvPr id="23" name="Text 21"/>
+          <p:cNvSpPr txBox="1"/>
+          <p:nvPr/>
+        </p:nvSpPr>
+        <p:spPr>
+          <a:xfrm>
+            <a:off x="9080500" y="2108200"/>
+            <a:ext cx="2070100" cy="177800"/>
+          </a:xfrm>
+          <a:prstGeom prst="rect">
+            <a:avLst/>
+          </a:prstGeom>
+          <a:noFill/>
+          <a:ln/>
+        </p:spPr>
+        <p:txBody>
+          <a:bodyPr wrap="square" lIns="0" tIns="0" rIns="0" bIns="0" rtlCol="0" anchor="t"/>
+          <a:lstStyle/>
+          <a:p>
+            <a:pPr algn="l" indent="0" marL="0">
+              <a:buNone/>
+            </a:pPr>
+            <a:r>
+              <a:rPr lang="en-US" sz="1050" b="1" spc="150" kern="0" dirty="0">
+                <a:solidFill>
+                  <a:srgbClr val="5A6472"/>
+                </a:solidFill>
+                <a:latin typeface="Arial" pitchFamily="34" charset="0"/>
+                <a:ea typeface="Arial" pitchFamily="34" charset="-122"/>
+                <a:cs typeface="Arial" pitchFamily="34" charset="-120"/>
+              </a:rPr>
+              <a:t>RESULT</a:t>
+            </a:r>
+            <a:endParaRPr lang="en-US" sz="1050" dirty="0"/>
+          </a:p>
+        </p:txBody>
+      </p:sp>
+      <p:sp>
+        <p:nvSpPr>
+          <p:cNvPr id="24" name="Text 22"/>
+          <p:cNvSpPr txBox="1"/>
+          <p:nvPr/>
+        </p:nvSpPr>
+        <p:spPr>
+          <a:xfrm>
+            <a:off x="9080500" y="2311400"/>
+            <a:ext cx="2070100" cy="190500"/>
+          </a:xfrm>
+          <a:prstGeom prst="rect">
+            <a:avLst/>
+          </a:prstGeom>
+          <a:noFill/>
+          <a:ln/>
+        </p:spPr>
+        <p:txBody>
+          <a:bodyPr wrap="square" lIns="0" tIns="0" rIns="0" bIns="0" rtlCol="0" anchor="t"/>
+          <a:lstStyle/>
+          <a:p>
+            <a:pPr algn="l" indent="0" marL="0">
+              <a:buNone/>
+            </a:pPr>
+            <a:r>
+              <a:rPr lang="en-US" sz="1300" dirty="0">
+                <a:solidFill>
+                  <a:srgbClr val="3D4A5C"/>
+                </a:solidFill>
+                <a:latin typeface="Arial" pitchFamily="34" charset="0"/>
+                <a:ea typeface="Arial" pitchFamily="34" charset="-122"/>
+                <a:cs typeface="Arial" pitchFamily="34" charset="-120"/>
+              </a:rPr>
+              <a:t>The result is</a:t>
+            </a:r>
+            <a:endParaRPr lang="en-US" sz="1300" dirty="0"/>
+          </a:p>
+        </p:txBody>
+      </p:sp>
+      <p:sp>
+        <p:nvSpPr>
+          <p:cNvPr id="25" name="Text 23"/>
+          <p:cNvSpPr txBox="1"/>
+          <p:nvPr/>
+        </p:nvSpPr>
+        <p:spPr>
+          <a:xfrm>
+            <a:off x="9080500" y="2540000"/>
+            <a:ext cx="2070100" cy="635000"/>
+          </a:xfrm>
+          <a:prstGeom prst="rect">
+            <a:avLst/>
+          </a:prstGeom>
+          <a:noFill/>
+          <a:ln/>
+        </p:spPr>
+        <p:txBody>
+          <a:bodyPr wrap="square" lIns="0" tIns="0" rIns="0" bIns="0" rtlCol="0" anchor="ctr"/>
+          <a:lstStyle/>
+          <a:p>
+            <a:pPr algn="l" indent="0" marL="0">
+              <a:lnSpc>
+                <a:spcPct val="95000"/>
+              </a:lnSpc>
+              <a:buNone/>
+            </a:pPr>
+            <a:r>
+              <a:rPr lang="en-US" sz="2600" b="1" dirty="0">
+                <a:solidFill>
+                  <a:srgbClr val="002554"/>
+                </a:solidFill>
+                <a:latin typeface="Maven Pro" pitchFamily="34" charset="0"/>
+                <a:ea typeface="Maven Pro" pitchFamily="34" charset="-122"/>
+                <a:cs typeface="Maven Pro" pitchFamily="34" charset="-120"/>
+              </a:rPr>
+              <a:t>GROWTH</a:t>
+            </a:r>
+            <a:endParaRPr lang="en-US" sz="2600" dirty="0"/>
+          </a:p>
+        </p:txBody>
+      </p:sp>
+      <p:sp>
+        <p:nvSpPr>
+          <p:cNvPr id="26" name="Shape 24"/>
+          <p:cNvSpPr/>
+          <p:nvPr/>
+        </p:nvSpPr>
+        <p:spPr>
+          <a:xfrm>
+            <a:off x="9080500" y="3302000"/>
+            <a:ext cx="2070100" cy="0"/>
+          </a:xfrm>
+          <a:prstGeom prst="line">
+            <a:avLst/>
+          </a:prstGeom>
+          <a:noFill/>
+          <a:ln w="19050">
+            <a:solidFill>
+              <a:srgbClr val="D6D0C2"/>
+            </a:solidFill>
+            <a:prstDash val="solid"/>
+          </a:ln>
+        </p:spPr>
+      </p:sp>
+      <p:sp>
+        <p:nvSpPr>
+          <p:cNvPr id="27" name="Text 25"/>
+          <p:cNvSpPr txBox="1"/>
+          <p:nvPr/>
+        </p:nvSpPr>
+        <p:spPr>
+          <a:xfrm>
+            <a:off x="9080500" y="3479800"/>
+            <a:ext cx="2070100" cy="2095500"/>
+          </a:xfrm>
+          <a:prstGeom prst="rect">
+            <a:avLst/>
+          </a:prstGeom>
+          <a:noFill/>
+          <a:ln/>
+        </p:spPr>
+        <p:txBody>
+          <a:bodyPr wrap="square" lIns="0" tIns="0" rIns="0" bIns="0" rtlCol="0" anchor="t"/>
+          <a:lstStyle/>
+          <a:p>
+            <a:pPr marL="177800" indent="-177800">
+              <a:spcAft>
+                <a:spcPts val="600"/>
+              </a:spcAft>
+              <a:buSzPct val="100000"/>
+              <a:buChar char="•"/>
+            </a:pPr>
+            <a:r>
+              <a:rPr lang="en-US" sz="1250" dirty="0">
+                <a:solidFill>
+                  <a:srgbClr val="3D4A5C"/>
+                </a:solidFill>
+                <a:latin typeface="Arial" pitchFamily="34" charset="0"/>
+                <a:ea typeface="Arial" pitchFamily="34" charset="-122"/>
+                <a:cs typeface="Arial" pitchFamily="34" charset="-120"/>
+              </a:rPr>
+              <a:t>Business growth: more referrals accepted with confidence</a:t>
+            </a:r>
+            <a:endParaRPr lang="en-US" sz="1250" dirty="0"/>
+          </a:p>
+          <a:p>
+            <a:pPr marL="177800" indent="-177800">
+              <a:spcAft>
+                <a:spcPts val="600"/>
+              </a:spcAft>
+              <a:buSzPct val="100000"/>
+              <a:buChar char="•"/>
+            </a:pPr>
+            <a:r>
+              <a:rPr lang="en-US" sz="1250" dirty="0">
+                <a:solidFill>
+                  <a:srgbClr val="3D4A5C"/>
+                </a:solidFill>
+                <a:latin typeface="Arial" pitchFamily="34" charset="0"/>
+                <a:ea typeface="Arial" pitchFamily="34" charset="-122"/>
+                <a:cs typeface="Arial" pitchFamily="34" charset="-120"/>
+              </a:rPr>
+              <a:t>Employee retention: time back for PCCs and clinicians</a:t>
+            </a:r>
+            <a:endParaRPr lang="en-US" sz="1250" dirty="0"/>
+          </a:p>
+          <a:p>
+            <a:pPr marL="177800" indent="-177800">
+              <a:spcAft>
+                <a:spcPts val="600"/>
+              </a:spcAft>
+              <a:buSzPct val="100000"/>
+              <a:buChar char="•"/>
+            </a:pPr>
+            <a:r>
+              <a:rPr lang="en-US" sz="1250" dirty="0">
+                <a:solidFill>
+                  <a:srgbClr val="3D4A5C"/>
+                </a:solidFill>
+                <a:latin typeface="Arial" pitchFamily="34" charset="0"/>
+                <a:ea typeface="Arial" pitchFamily="34" charset="-122"/>
+                <a:cs typeface="Arial" pitchFamily="34" charset="-120"/>
+              </a:rPr>
+              <a:t>More patients served</a:t>
+            </a:r>
+            <a:endParaRPr lang="en-US" sz="1250" dirty="0"/>
+          </a:p>
+        </p:txBody>
+      </p:sp>
+      <p:sp>
+        <p:nvSpPr>
+          <p:cNvPr id="25" name="Slide Number Placeholder 0"/>
+          <p:cNvSpPr>
+            <a:spLocks noGrp="1"/>
+          </p:cNvSpPr>
+          <p:nvPr>
+            <p:ph type="sldNum" sz="quarter" idx="4294967295"/>
+          </p:nvPr>
+        </p:nvSpPr>
+        <p:spPr>
+          <a:xfrm>
+            <a:off x="10109200" y="6197600"/>
+            <a:ext cx="1270000" cy="254000"/>
+          </a:xfrm>
+          <a:prstGeom prst="rect">
+            <a:avLst/>
+          </a:prstGeom>
+          <a:extLst>
+            <a:ext uri="{C572A759-6A51-4108-AA02-DFA0A04FC94B}">
+              <ma14:wrappingTextBoxFlag xmlns:ma14="http://schemas.microsoft.com/office/mac/drawingml/2011/main" val="0"/>
+            </a:ext>
+          </a:extLst>
+        </p:spPr>
+        <p:txBody>
+          <a:bodyPr anchor="ctr"/>
+          <a:lstStyle>
+            <a:lvl1pPr>
+              <a:defRPr sz="1200">
+                <a:solidFill>
+                  <a:srgbClr val="5A6472"/>
+                </a:solidFill>
+                <a:latin typeface="Arial"/>
+                <a:ea typeface="Arial"/>
+                <a:cs typeface="Arial"/>
+              </a:defRPr>
+            </a:lvl1pPr>
+          </a:lstStyle>
+          <a:p>
+            <a:pPr algn="r"/>
+            <a:fld id="{F7021451-1387-4CA6-816F-3879F97B5CBC}" type="slidenum">
+              <a:rPr b="0" lang="en-US"/>
+              <a:t>2</a:t>
+            </a:fld>
+            <a:endParaRPr lang="en-US"/>
+          </a:p>
+        </p:txBody>
+      </p:sp>
+    </p:spTree>
+  </p:cSld>
+  <p:clrMapOvr>
+    <a:masterClrMapping/>
+  </p:clrMapOvr>
+</p:sld>
+</file>
+
+<file path=ppt/slides/slide3.xml><?xml version="1.0" encoding="utf-8"?>
+<p:sld xmlns:a="http://schemas.openxmlformats.org/drawingml/2006/main" xmlns:r="http://schemas.openxmlformats.org/officeDocument/2006/relationships" xmlns:p="http://schemas.openxmlformats.org/presentationml/2006/main">
+  <p:cSld name="Slide 3">
+    <p:spTree>
+      <p:nvGrpSpPr>
+        <p:cNvPr id="1" name=""/>
+        <p:cNvGrpSpPr/>
+        <p:nvPr/>
+      </p:nvGrpSpPr>
+      <p:grpSpPr>
+        <a:xfrm>
+          <a:off x="0" y="0"/>
+          <a:ext cx="0" cy="0"/>
+          <a:chOff x="0" y="0"/>
+          <a:chExt cx="0" cy="0"/>
+        </a:xfrm>
+      </p:grpSpPr>
+      <p:sp>
+        <p:nvSpPr>
+          <p:cNvPr id="2" name="Text 1"/>
+          <p:cNvSpPr/>
+          <p:nvPr>
+            <p:ph idx="102" type="body" hasCustomPrompt="1"/>
+          </p:nvPr>
+        </p:nvSpPr>
+        <p:spPr>
+          <a:xfrm>
+            <a:off x="812800" y="812800"/>
+            <a:ext cx="10566400" cy="254000"/>
+          </a:xfrm>
+          <a:prstGeom prst="rect">
+            <a:avLst/>
+          </a:prstGeom>
+          <a:noFill/>
+          <a:ln/>
+        </p:spPr>
+        <p:txBody>
+          <a:bodyPr wrap="square" lIns="0" tIns="0" rIns="0" bIns="0" rtlCol="0" anchor="t"/>
+          <a:lstStyle/>
+          <a:p>
+            <a:pPr indent="0" marL="0">
+              <a:buNone/>
+            </a:pPr>
+            <a:r>
+              <a:rPr lang="en-US" sz="1200" b="1" spc="200" kern="0" dirty="0">
+                <a:solidFill>
+                  <a:srgbClr val="8A5F00"/>
+                </a:solidFill>
+                <a:latin typeface="Arial" pitchFamily="34" charset="0"/>
+                <a:ea typeface="Arial" pitchFamily="34" charset="-122"/>
+                <a:cs typeface="Arial" pitchFamily="34" charset="-120"/>
+              </a:rPr>
+              <a:t>MESSAGE FRAME · EXAMPLE STORY</a:t>
+            </a:r>
+            <a:endParaRPr lang="en-US" sz="1200" dirty="0"/>
+          </a:p>
+        </p:txBody>
+      </p:sp>
+      <p:sp>
+        <p:nvSpPr>
+          <p:cNvPr id="3" name="Text 1"/>
+          <p:cNvSpPr/>
+          <p:nvPr>
+            <p:ph idx="103" type="title" hasCustomPrompt="1"/>
+          </p:nvPr>
+        </p:nvSpPr>
+        <p:spPr>
+          <a:xfrm>
+            <a:off x="812800" y="1117600"/>
+            <a:ext cx="10566400" cy="635000"/>
+          </a:xfrm>
+          <a:prstGeom prst="rect">
+            <a:avLst/>
+          </a:prstGeom>
+          <a:noFill/>
+          <a:ln/>
+        </p:spPr>
+        <p:txBody>
+          <a:bodyPr wrap="square" lIns="0" tIns="0" rIns="0" bIns="0" rtlCol="0" anchor="t"/>
+          <a:lstStyle/>
+          <a:p>
+            <a:pPr algn="l" indent="0" marL="0">
+              <a:buNone/>
+            </a:pPr>
+            <a:r>
+              <a:rPr lang="en-US" sz="4000" dirty="0">
+                <a:solidFill>
+                  <a:srgbClr val="002554"/>
+                </a:solidFill>
+                <a:latin typeface="Maven Pro" pitchFamily="34" charset="0"/>
+                <a:ea typeface="Maven Pro" pitchFamily="34" charset="-122"/>
+                <a:cs typeface="Maven Pro" pitchFamily="34" charset="-120"/>
+              </a:rPr>
+              <a:t>How it sounds out loud</a:t>
+            </a:r>
+            <a:endParaRPr lang="en-US" sz="4000" dirty="0"/>
+          </a:p>
+        </p:txBody>
+      </p:sp>
+      <p:sp>
+        <p:nvSpPr>
+          <p:cNvPr id="4" name="Text 2"/>
+          <p:cNvSpPr txBox="1"/>
+          <p:nvPr/>
+        </p:nvSpPr>
+        <p:spPr>
+          <a:xfrm>
+            <a:off x="812800" y="1841500"/>
+            <a:ext cx="10566400" cy="215900"/>
+          </a:xfrm>
+          <a:prstGeom prst="rect">
+            <a:avLst/>
+          </a:prstGeom>
+          <a:noFill/>
+          <a:ln/>
+        </p:spPr>
+        <p:txBody>
+          <a:bodyPr wrap="square" lIns="0" tIns="0" rIns="0" bIns="0" rtlCol="0" anchor="t"/>
+          <a:lstStyle/>
+          <a:p>
+            <a:pPr algn="l" indent="0" marL="0">
+              <a:buNone/>
+            </a:pPr>
+            <a:r>
+              <a:rPr lang="en-US" sz="1300" dirty="0">
+                <a:solidFill>
+                  <a:srgbClr val="5A6472"/>
+                </a:solidFill>
+                <a:latin typeface="Arial" pitchFamily="34" charset="0"/>
+                <a:ea typeface="Arial" pitchFamily="34" charset="-122"/>
+                <a:cs typeface="Arial" pitchFamily="34" charset="-120"/>
+              </a:rPr>
+              <a:t>The four anchor words stay the same, always. The facts and examples change to fit the listener.</a:t>
+            </a:r>
+            <a:endParaRPr lang="en-US" sz="1300" dirty="0"/>
+          </a:p>
+        </p:txBody>
+      </p:sp>
+      <p:sp>
+        <p:nvSpPr>
+          <p:cNvPr id="5" name="Text 3"/>
+          <p:cNvSpPr txBox="1"/>
+          <p:nvPr/>
+        </p:nvSpPr>
+        <p:spPr>
+          <a:xfrm>
+            <a:off x="1270000" y="2222500"/>
+            <a:ext cx="9652000" cy="3556000"/>
+          </a:xfrm>
+          <a:prstGeom prst="rect">
+            <a:avLst/>
+          </a:prstGeom>
+          <a:noFill/>
+          <a:ln/>
+        </p:spPr>
+        <p:txBody>
+          <a:bodyPr wrap="square" lIns="0" tIns="0" rIns="0" bIns="0" rtlCol="0" anchor="ctr"/>
+          <a:lstStyle/>
+          <a:p>
+            <a:pPr indent="0" marL="0">
+              <a:lnSpc>
+                <a:spcPct val="120000"/>
+              </a:lnSpc>
+              <a:spcAft>
+                <a:spcPts val="1200"/>
+              </a:spcAft>
+              <a:buNone/>
+            </a:pPr>
+            <a:r>
+              <a:rPr lang="en-US" sz="1700" dirty="0">
+                <a:solidFill>
+                  <a:srgbClr val="002554"/>
+                </a:solidFill>
+                <a:latin typeface="Maven Pro" pitchFamily="34" charset="0"/>
+                <a:ea typeface="Maven Pro" pitchFamily="34" charset="-122"/>
+                <a:cs typeface="Maven Pro" pitchFamily="34" charset="-120"/>
+              </a:rPr>
+              <a:t>“Every day, our branches make hundreds of capacity and scheduling </a:t>
+            </a:r>
+            <a:pPr indent="0" marL="0">
+              <a:lnSpc>
+                <a:spcPct val="120000"/>
+              </a:lnSpc>
+              <a:spcAft>
+                <a:spcPts val="1200"/>
+              </a:spcAft>
+              <a:buNone/>
+            </a:pPr>
+            <a:r>
+              <a:rPr lang="en-US" sz="1700" b="1" dirty="0">
+                <a:solidFill>
+                  <a:srgbClr val="8A5F00"/>
+                </a:solidFill>
+                <a:latin typeface="Maven Pro" pitchFamily="34" charset="0"/>
+                <a:ea typeface="Maven Pro" pitchFamily="34" charset="-122"/>
+                <a:cs typeface="Maven Pro" pitchFamily="34" charset="-120"/>
+              </a:rPr>
+              <a:t>decisions</a:t>
+            </a:r>
+            <a:pPr indent="0" marL="0">
+              <a:lnSpc>
+                <a:spcPct val="120000"/>
+              </a:lnSpc>
+              <a:spcAft>
+                <a:spcPts val="1200"/>
+              </a:spcAft>
+              <a:buNone/>
+            </a:pPr>
+            <a:r>
+              <a:rPr lang="en-US" sz="1700" dirty="0">
+                <a:solidFill>
+                  <a:srgbClr val="002554"/>
+                </a:solidFill>
+                <a:latin typeface="Maven Pro" pitchFamily="34" charset="0"/>
+                <a:ea typeface="Maven Pro" pitchFamily="34" charset="-122"/>
+                <a:cs typeface="Maven Pro" pitchFamily="34" charset="-120"/>
+              </a:rPr>
+              <a:t>. Today those decisions are hard, disjointed and complex. The information lives in HCHB, spreadsheets, Workday and people's memories, so our PCCs and clinicians spend their time piecing it together.</a:t>
+            </a:r>
+            <a:endParaRPr lang="en-US" sz="1700" dirty="0"/>
+          </a:p>
+          <a:p>
+            <a:pPr indent="0" marL="0">
+              <a:lnSpc>
+                <a:spcPct val="120000"/>
+              </a:lnSpc>
+              <a:spcAft>
+                <a:spcPts val="1200"/>
+              </a:spcAft>
+              <a:buNone/>
+            </a:pPr>
+            <a:r>
+              <a:rPr lang="en-US" sz="1700" dirty="0">
+                <a:solidFill>
+                  <a:srgbClr val="002554"/>
+                </a:solidFill>
+                <a:latin typeface="Maven Pro" pitchFamily="34" charset="0"/>
+                <a:ea typeface="Maven Pro" pitchFamily="34" charset="-122"/>
+                <a:cs typeface="Maven Pro" pitchFamily="34" charset="-120"/>
+              </a:rPr>
+              <a:t>We need those decisions </a:t>
+            </a:r>
+            <a:pPr indent="0" marL="0">
+              <a:lnSpc>
+                <a:spcPct val="120000"/>
+              </a:lnSpc>
+              <a:spcAft>
+                <a:spcPts val="1200"/>
+              </a:spcAft>
+              <a:buNone/>
+            </a:pPr>
+            <a:r>
+              <a:rPr lang="en-US" sz="1700" b="1" dirty="0">
+                <a:solidFill>
+                  <a:srgbClr val="8A5F00"/>
+                </a:solidFill>
+                <a:latin typeface="Maven Pro" pitchFamily="34" charset="0"/>
+                <a:ea typeface="Maven Pro" pitchFamily="34" charset="-122"/>
+                <a:cs typeface="Maven Pro" pitchFamily="34" charset="-120"/>
+              </a:rPr>
+              <a:t>optimized</a:t>
+            </a:r>
+            <a:pPr indent="0" marL="0">
+              <a:lnSpc>
+                <a:spcPct val="120000"/>
+              </a:lnSpc>
+              <a:spcAft>
+                <a:spcPts val="1200"/>
+              </a:spcAft>
+              <a:buNone/>
+            </a:pPr>
+            <a:r>
+              <a:rPr lang="en-US" sz="1700" dirty="0">
+                <a:solidFill>
+                  <a:srgbClr val="002554"/>
+                </a:solidFill>
+                <a:latin typeface="Maven Pro" pitchFamily="34" charset="0"/>
+                <a:ea typeface="Maven Pro" pitchFamily="34" charset="-122"/>
+                <a:cs typeface="Maven Pro" pitchFamily="34" charset="-120"/>
+              </a:rPr>
+              <a:t>: capacity visible at a glance, the repetitive steps automated, and clear recommendations that show their reasoning.</a:t>
+            </a:r>
+            <a:endParaRPr lang="en-US" sz="1700" dirty="0"/>
+          </a:p>
+          <a:p>
+            <a:pPr indent="0" marL="0">
+              <a:lnSpc>
+                <a:spcPct val="120000"/>
+              </a:lnSpc>
+              <a:spcAft>
+                <a:spcPts val="1200"/>
+              </a:spcAft>
+              <a:buNone/>
+            </a:pPr>
+            <a:r>
+              <a:rPr lang="en-US" sz="1700" dirty="0">
+                <a:solidFill>
+                  <a:srgbClr val="002554"/>
+                </a:solidFill>
+                <a:latin typeface="Maven Pro" pitchFamily="34" charset="0"/>
+                <a:ea typeface="Maven Pro" pitchFamily="34" charset="-122"/>
+                <a:cs typeface="Maven Pro" pitchFamily="34" charset="-120"/>
+              </a:rPr>
+              <a:t>Our approach is </a:t>
+            </a:r>
+            <a:pPr indent="0" marL="0">
+              <a:lnSpc>
+                <a:spcPct val="120000"/>
+              </a:lnSpc>
+              <a:spcAft>
+                <a:spcPts val="1200"/>
+              </a:spcAft>
+              <a:buNone/>
+            </a:pPr>
+            <a:r>
+              <a:rPr lang="en-US" sz="1700" b="1" dirty="0">
+                <a:solidFill>
+                  <a:srgbClr val="8A5F00"/>
+                </a:solidFill>
+                <a:latin typeface="Maven Pro" pitchFamily="34" charset="0"/>
+                <a:ea typeface="Maven Pro" pitchFamily="34" charset="-122"/>
+                <a:cs typeface="Maven Pro" pitchFamily="34" charset="-120"/>
+              </a:rPr>
+              <a:t>clinician-centered</a:t>
+            </a:r>
+            <a:pPr indent="0" marL="0">
+              <a:lnSpc>
+                <a:spcPct val="120000"/>
+              </a:lnSpc>
+              <a:spcAft>
+                <a:spcPts val="1200"/>
+              </a:spcAft>
+              <a:buNone/>
+            </a:pPr>
+            <a:r>
+              <a:rPr lang="en-US" sz="1700" dirty="0">
+                <a:solidFill>
+                  <a:srgbClr val="002554"/>
+                </a:solidFill>
+                <a:latin typeface="Maven Pro" pitchFamily="34" charset="0"/>
+                <a:ea typeface="Maven Pro" pitchFamily="34" charset="-122"/>
+                <a:cs typeface="Maven Pro" pitchFamily="34" charset="-120"/>
+              </a:rPr>
+              <a:t>. The people who do the work are helping choose the tool, we are protecting the flexibility clinicians value, and we will prove it in a measured pilot before we scale.</a:t>
+            </a:r>
+            <a:endParaRPr lang="en-US" sz="1700" dirty="0"/>
+          </a:p>
+          <a:p>
+            <a:pPr indent="0" marL="0">
+              <a:lnSpc>
+                <a:spcPct val="120000"/>
+              </a:lnSpc>
+              <a:spcAft>
+                <a:spcPts val="1200"/>
+              </a:spcAft>
+              <a:buNone/>
+            </a:pPr>
+            <a:r>
+              <a:rPr lang="en-US" sz="1700" dirty="0">
+                <a:solidFill>
+                  <a:srgbClr val="002554"/>
+                </a:solidFill>
+                <a:latin typeface="Maven Pro" pitchFamily="34" charset="0"/>
+                <a:ea typeface="Maven Pro" pitchFamily="34" charset="-122"/>
+                <a:cs typeface="Maven Pro" pitchFamily="34" charset="-120"/>
+              </a:rPr>
+              <a:t>The result is </a:t>
+            </a:r>
+            <a:pPr indent="0" marL="0">
+              <a:lnSpc>
+                <a:spcPct val="120000"/>
+              </a:lnSpc>
+              <a:spcAft>
+                <a:spcPts val="1200"/>
+              </a:spcAft>
+              <a:buNone/>
+            </a:pPr>
+            <a:r>
+              <a:rPr lang="en-US" sz="1700" b="1" dirty="0">
+                <a:solidFill>
+                  <a:srgbClr val="8A5F00"/>
+                </a:solidFill>
+                <a:latin typeface="Maven Pro" pitchFamily="34" charset="0"/>
+                <a:ea typeface="Maven Pro" pitchFamily="34" charset="-122"/>
+                <a:cs typeface="Maven Pro" pitchFamily="34" charset="-120"/>
+              </a:rPr>
+              <a:t>growth</a:t>
+            </a:r>
+            <a:pPr indent="0" marL="0">
+              <a:lnSpc>
+                <a:spcPct val="120000"/>
+              </a:lnSpc>
+              <a:spcAft>
+                <a:spcPts val="1200"/>
+              </a:spcAft>
+              <a:buNone/>
+            </a:pPr>
+            <a:r>
+              <a:rPr lang="en-US" sz="1700" dirty="0">
+                <a:solidFill>
+                  <a:srgbClr val="002554"/>
+                </a:solidFill>
+                <a:latin typeface="Maven Pro" pitchFamily="34" charset="0"/>
+                <a:ea typeface="Maven Pro" pitchFamily="34" charset="-122"/>
+                <a:cs typeface="Maven Pro" pitchFamily="34" charset="-120"/>
+              </a:rPr>
+              <a:t>: branches that can say yes to more referrals, teams that want to stay, and more patients served.”</a:t>
+            </a:r>
+            <a:endParaRPr lang="en-US" sz="1700" dirty="0"/>
+          </a:p>
+        </p:txBody>
+      </p:sp>
+      <p:sp>
+        <p:nvSpPr>
+          <p:cNvPr id="25" name="Slide Number Placeholder 0"/>
+          <p:cNvSpPr>
+            <a:spLocks noGrp="1"/>
+          </p:cNvSpPr>
+          <p:nvPr>
+            <p:ph type="sldNum" sz="quarter" idx="4294967295"/>
+          </p:nvPr>
+        </p:nvSpPr>
+        <p:spPr>
+          <a:xfrm>
+            <a:off x="10109200" y="6197600"/>
+            <a:ext cx="1270000" cy="254000"/>
+          </a:xfrm>
+          <a:prstGeom prst="rect">
+            <a:avLst/>
+          </a:prstGeom>
+          <a:extLst>
+            <a:ext uri="{C572A759-6A51-4108-AA02-DFA0A04FC94B}">
+              <ma14:wrappingTextBoxFlag xmlns:ma14="http://schemas.microsoft.com/office/mac/drawingml/2011/main" val="0"/>
+            </a:ext>
+          </a:extLst>
+        </p:spPr>
+        <p:txBody>
+          <a:bodyPr anchor="ctr"/>
+          <a:lstStyle>
+            <a:lvl1pPr>
+              <a:defRPr sz="1200">
+                <a:solidFill>
+                  <a:srgbClr val="5A6472"/>
+                </a:solidFill>
+                <a:latin typeface="Arial"/>
+                <a:ea typeface="Arial"/>
+                <a:cs typeface="Arial"/>
+              </a:defRPr>
+            </a:lvl1pPr>
+          </a:lstStyle>
+          <a:p>
+            <a:pPr algn="r"/>
+            <a:fld id="{F7021451-1387-4CA6-816F-3879F97B5CBC}" type="slidenum">
+              <a:rPr b="0" lang="en-US"/>
+              <a:t>3</a:t>
             </a:fld>
             <a:endParaRPr lang="en-US"/>
           </a:p>

</xml_diff>